<commit_message>
updated Day 1 decks
</commit_message>
<xml_diff>
--- a/decks/Day 1/Section1-Foundations-Claude-Code-CLI.pptx
+++ b/decks/Day 1/Section1-Foundations-Claude-Code-CLI.pptx
@@ -4,6 +4,9 @@
   <p:sldMasterIdLst>
     <p:sldMasterId id="2147483648" r:id="rId1"/>
   </p:sldMasterIdLst>
+  <p:notesMasterIdLst>
+    <p:notesMasterId r:id="rId16"/>
+  </p:notesMasterIdLst>
   <p:sldIdLst>
     <p:sldId id="256" r:id="rId2"/>
     <p:sldId id="257" r:id="rId3"/>
@@ -13,11 +16,12 @@
     <p:sldId id="261" r:id="rId7"/>
     <p:sldId id="262" r:id="rId8"/>
     <p:sldId id="263" r:id="rId9"/>
-    <p:sldId id="264" r:id="rId10"/>
-    <p:sldId id="265" r:id="rId11"/>
-    <p:sldId id="266" r:id="rId12"/>
-    <p:sldId id="267" r:id="rId13"/>
-    <p:sldId id="268" r:id="rId14"/>
+    <p:sldId id="269" r:id="rId10"/>
+    <p:sldId id="264" r:id="rId11"/>
+    <p:sldId id="265" r:id="rId12"/>
+    <p:sldId id="266" r:id="rId13"/>
+    <p:sldId id="267" r:id="rId14"/>
+    <p:sldId id="268" r:id="rId15"/>
   </p:sldIdLst>
   <p:sldSz cx="9144000" cy="5143500" type="screen16x9"/>
   <p:notesSz cx="5143500" cy="9144000"/>
@@ -119,6 +123,1223 @@
     </p:ext>
   </p:extLst>
 </p:presentation>
+</file>
+
+<file path=ppt/notesMasters/notesMaster1.xml><?xml version="1.0" encoding="utf-8"?>
+<p:notesMaster xmlns:a="http://schemas.openxmlformats.org/drawingml/2006/main" xmlns:r="http://schemas.openxmlformats.org/officeDocument/2006/relationships" xmlns:p="http://schemas.openxmlformats.org/presentationml/2006/main">
+  <p:cSld>
+    <p:bg>
+      <p:bgRef idx="1001">
+        <a:schemeClr val="bg1"/>
+      </p:bgRef>
+    </p:bg>
+    <p:spTree>
+      <p:nvGrpSpPr>
+        <p:cNvPr id="1" name=""/>
+        <p:cNvGrpSpPr/>
+        <p:nvPr/>
+      </p:nvGrpSpPr>
+      <p:grpSpPr>
+        <a:xfrm>
+          <a:off x="0" y="0"/>
+          <a:ext cx="0" cy="0"/>
+          <a:chOff x="0" y="0"/>
+          <a:chExt cx="0" cy="0"/>
+        </a:xfrm>
+      </p:grpSpPr>
+    </p:spTree>
+    <p:extLst>
+      <p:ext uri="{BB962C8B-B14F-4D97-AF65-F5344CB8AC3E}">
+        <p14:creationId xmlns:p14="http://schemas.microsoft.com/office/powerpoint/2010/main" val="2766722189"/>
+      </p:ext>
+    </p:extLst>
+  </p:cSld>
+  <p:clrMap bg1="lt1" tx1="dk1" bg2="lt2" tx2="dk2" accent1="accent1" accent2="accent2" accent3="accent3" accent4="accent4" accent5="accent5" accent6="accent6" hlink="hlink" folHlink="folHlink"/>
+  <p:notesStyle>
+    <a:lvl1pPr marL="0" algn="l" defTabSz="914400" rtl="0" eaLnBrk="1" latinLnBrk="0" hangingPunct="1">
+      <a:defRPr sz="1200" kern="1200">
+        <a:solidFill>
+          <a:schemeClr val="tx1"/>
+        </a:solidFill>
+        <a:latin typeface="+mn-lt"/>
+        <a:ea typeface="+mn-ea"/>
+        <a:cs typeface="+mn-cs"/>
+      </a:defRPr>
+    </a:lvl1pPr>
+    <a:lvl2pPr marL="457200" algn="l" defTabSz="914400" rtl="0" eaLnBrk="1" latinLnBrk="0" hangingPunct="1">
+      <a:defRPr sz="1200" kern="1200">
+        <a:solidFill>
+          <a:schemeClr val="tx1"/>
+        </a:solidFill>
+        <a:latin typeface="+mn-lt"/>
+        <a:ea typeface="+mn-ea"/>
+        <a:cs typeface="+mn-cs"/>
+      </a:defRPr>
+    </a:lvl2pPr>
+    <a:lvl3pPr marL="914400" algn="l" defTabSz="914400" rtl="0" eaLnBrk="1" latinLnBrk="0" hangingPunct="1">
+      <a:defRPr sz="1200" kern="1200">
+        <a:solidFill>
+          <a:schemeClr val="tx1"/>
+        </a:solidFill>
+        <a:latin typeface="+mn-lt"/>
+        <a:ea typeface="+mn-ea"/>
+        <a:cs typeface="+mn-cs"/>
+      </a:defRPr>
+    </a:lvl3pPr>
+    <a:lvl4pPr marL="1371600" algn="l" defTabSz="914400" rtl="0" eaLnBrk="1" latinLnBrk="0" hangingPunct="1">
+      <a:defRPr sz="1200" kern="1200">
+        <a:solidFill>
+          <a:schemeClr val="tx1"/>
+        </a:solidFill>
+        <a:latin typeface="+mn-lt"/>
+        <a:ea typeface="+mn-ea"/>
+        <a:cs typeface="+mn-cs"/>
+      </a:defRPr>
+    </a:lvl4pPr>
+    <a:lvl5pPr marL="1828800" algn="l" defTabSz="914400" rtl="0" eaLnBrk="1" latinLnBrk="0" hangingPunct="1">
+      <a:defRPr sz="1200" kern="1200">
+        <a:solidFill>
+          <a:schemeClr val="tx1"/>
+        </a:solidFill>
+        <a:latin typeface="+mn-lt"/>
+        <a:ea typeface="+mn-ea"/>
+        <a:cs typeface="+mn-cs"/>
+      </a:defRPr>
+    </a:lvl5pPr>
+    <a:lvl6pPr marL="2286000" algn="l" defTabSz="914400" rtl="0" eaLnBrk="1" latinLnBrk="0" hangingPunct="1">
+      <a:defRPr sz="1200" kern="1200">
+        <a:solidFill>
+          <a:schemeClr val="tx1"/>
+        </a:solidFill>
+        <a:latin typeface="+mn-lt"/>
+        <a:ea typeface="+mn-ea"/>
+        <a:cs typeface="+mn-cs"/>
+      </a:defRPr>
+    </a:lvl6pPr>
+    <a:lvl7pPr marL="2743200" algn="l" defTabSz="914400" rtl="0" eaLnBrk="1" latinLnBrk="0" hangingPunct="1">
+      <a:defRPr sz="1200" kern="1200">
+        <a:solidFill>
+          <a:schemeClr val="tx1"/>
+        </a:solidFill>
+        <a:latin typeface="+mn-lt"/>
+        <a:ea typeface="+mn-ea"/>
+        <a:cs typeface="+mn-cs"/>
+      </a:defRPr>
+    </a:lvl7pPr>
+    <a:lvl8pPr marL="3200400" algn="l" defTabSz="914400" rtl="0" eaLnBrk="1" latinLnBrk="0" hangingPunct="1">
+      <a:defRPr sz="1200" kern="1200">
+        <a:solidFill>
+          <a:schemeClr val="tx1"/>
+        </a:solidFill>
+        <a:latin typeface="+mn-lt"/>
+        <a:ea typeface="+mn-ea"/>
+        <a:cs typeface="+mn-cs"/>
+      </a:defRPr>
+    </a:lvl8pPr>
+    <a:lvl9pPr marL="3657600" algn="l" defTabSz="914400" rtl="0" eaLnBrk="1" latinLnBrk="0" hangingPunct="1">
+      <a:defRPr sz="1200" kern="1200">
+        <a:solidFill>
+          <a:schemeClr val="tx1"/>
+        </a:solidFill>
+        <a:latin typeface="+mn-lt"/>
+        <a:ea typeface="+mn-ea"/>
+        <a:cs typeface="+mn-cs"/>
+      </a:defRPr>
+    </a:lvl9pPr>
+  </p:notesStyle>
+</p:notesMaster>
+</file>
+
+<file path=ppt/notesSlides/notesSlide1.xml><?xml version="1.0" encoding="utf-8"?>
+<p:notes xmlns:a="http://schemas.openxmlformats.org/drawingml/2006/main" xmlns:r="http://schemas.openxmlformats.org/officeDocument/2006/relationships" xmlns:p="http://schemas.openxmlformats.org/presentationml/2006/main">
+  <p:cSld>
+    <p:spTree>
+      <p:nvGrpSpPr>
+        <p:cNvPr id="1" name=""/>
+        <p:cNvGrpSpPr/>
+        <p:nvPr/>
+      </p:nvGrpSpPr>
+      <p:grpSpPr>
+        <a:xfrm>
+          <a:off x="0" y="0"/>
+          <a:ext cx="0" cy="0"/>
+          <a:chOff x="0" y="0"/>
+          <a:chExt cx="0" cy="0"/>
+        </a:xfrm>
+      </p:grpSpPr>
+      <p:sp>
+        <p:nvSpPr>
+          <p:cNvPr id="2" name="Slide Image Placeholder 1"/>
+          <p:cNvSpPr>
+            <a:spLocks noGrp="1" noRot="1" noChangeAspect="1"/>
+          </p:cNvSpPr>
+          <p:nvPr>
+            <p:ph type="sldImg"/>
+          </p:nvPr>
+        </p:nvSpPr>
+        <p:spPr/>
+      </p:sp>
+      <p:sp>
+        <p:nvSpPr>
+          <p:cNvPr id="3" name="Notes Placeholder 2"/>
+          <p:cNvSpPr>
+            <a:spLocks noGrp="1"/>
+          </p:cNvSpPr>
+          <p:nvPr>
+            <p:ph type="body" idx="1"/>
+          </p:nvPr>
+        </p:nvSpPr>
+        <p:spPr/>
+        <p:txBody>
+          <a:bodyPr/>
+          <a:lstStyle/>
+          <a:p>
+            <a:endParaRPr lang="en-US" dirty="0"/>
+          </a:p>
+        </p:txBody>
+      </p:sp>
+      <p:sp>
+        <p:nvSpPr>
+          <p:cNvPr id="4" name="Slide Number Placeholder 3"/>
+          <p:cNvSpPr>
+            <a:spLocks noGrp="1"/>
+          </p:cNvSpPr>
+          <p:nvPr>
+            <p:ph type="sldNum" sz="quarter" idx="10"/>
+          </p:nvPr>
+        </p:nvSpPr>
+        <p:spPr/>
+        <p:txBody>
+          <a:bodyPr/>
+          <a:lstStyle/>
+          <a:p>
+            <a:fld id="{F7021451-1387-4CA6-816F-3879F97B5CBC}" type="slidenum">
+              <a:rPr lang="en-US"/>
+              <a:t>1</a:t>
+            </a:fld>
+            <a:endParaRPr lang="en-US"/>
+          </a:p>
+        </p:txBody>
+      </p:sp>
+    </p:spTree>
+    <p:extLst>
+      <p:ext uri="{BB962C8B-B14F-4D97-AF65-F5344CB8AC3E}">
+        <p14:creationId xmlns:p14="http://schemas.microsoft.com/office/powerpoint/2010/main" val="1024086991"/>
+      </p:ext>
+    </p:extLst>
+  </p:cSld>
+  <p:clrMapOvr>
+    <a:masterClrMapping/>
+  </p:clrMapOvr>
+</p:notes>
+</file>
+
+<file path=ppt/notesSlides/notesSlide10.xml><?xml version="1.0" encoding="utf-8"?>
+<p:notes xmlns:a="http://schemas.openxmlformats.org/drawingml/2006/main" xmlns:r="http://schemas.openxmlformats.org/officeDocument/2006/relationships" xmlns:p="http://schemas.openxmlformats.org/presentationml/2006/main">
+  <p:cSld>
+    <p:spTree>
+      <p:nvGrpSpPr>
+        <p:cNvPr id="1" name=""/>
+        <p:cNvGrpSpPr/>
+        <p:nvPr/>
+      </p:nvGrpSpPr>
+      <p:grpSpPr>
+        <a:xfrm>
+          <a:off x="0" y="0"/>
+          <a:ext cx="0" cy="0"/>
+          <a:chOff x="0" y="0"/>
+          <a:chExt cx="0" cy="0"/>
+        </a:xfrm>
+      </p:grpSpPr>
+      <p:sp>
+        <p:nvSpPr>
+          <p:cNvPr id="2" name="Slide Image Placeholder 1"/>
+          <p:cNvSpPr>
+            <a:spLocks noGrp="1" noRot="1" noChangeAspect="1"/>
+          </p:cNvSpPr>
+          <p:nvPr>
+            <p:ph type="sldImg"/>
+          </p:nvPr>
+        </p:nvSpPr>
+        <p:spPr/>
+      </p:sp>
+      <p:sp>
+        <p:nvSpPr>
+          <p:cNvPr id="3" name="Notes Placeholder 2"/>
+          <p:cNvSpPr>
+            <a:spLocks noGrp="1"/>
+          </p:cNvSpPr>
+          <p:nvPr>
+            <p:ph type="body" idx="1"/>
+          </p:nvPr>
+        </p:nvSpPr>
+        <p:spPr/>
+        <p:txBody>
+          <a:bodyPr/>
+          <a:lstStyle/>
+          <a:p>
+            <a:endParaRPr lang="en-US" dirty="0"/>
+          </a:p>
+        </p:txBody>
+      </p:sp>
+      <p:sp>
+        <p:nvSpPr>
+          <p:cNvPr id="4" name="Slide Number Placeholder 3"/>
+          <p:cNvSpPr>
+            <a:spLocks noGrp="1"/>
+          </p:cNvSpPr>
+          <p:nvPr>
+            <p:ph type="sldNum" sz="quarter" idx="10"/>
+          </p:nvPr>
+        </p:nvSpPr>
+        <p:spPr/>
+        <p:txBody>
+          <a:bodyPr/>
+          <a:lstStyle/>
+          <a:p>
+            <a:fld id="{F7021451-1387-4CA6-816F-3879F97B5CBC}" type="slidenum">
+              <a:rPr lang="en-US"/>
+              <a:t>11</a:t>
+            </a:fld>
+            <a:endParaRPr lang="en-US"/>
+          </a:p>
+        </p:txBody>
+      </p:sp>
+    </p:spTree>
+    <p:extLst>
+      <p:ext uri="{BB962C8B-B14F-4D97-AF65-F5344CB8AC3E}">
+        <p14:creationId xmlns:p14="http://schemas.microsoft.com/office/powerpoint/2010/main" val="1024086991"/>
+      </p:ext>
+    </p:extLst>
+  </p:cSld>
+  <p:clrMapOvr>
+    <a:masterClrMapping/>
+  </p:clrMapOvr>
+</p:notes>
+</file>
+
+<file path=ppt/notesSlides/notesSlide11.xml><?xml version="1.0" encoding="utf-8"?>
+<p:notes xmlns:a="http://schemas.openxmlformats.org/drawingml/2006/main" xmlns:r="http://schemas.openxmlformats.org/officeDocument/2006/relationships" xmlns:p="http://schemas.openxmlformats.org/presentationml/2006/main">
+  <p:cSld>
+    <p:spTree>
+      <p:nvGrpSpPr>
+        <p:cNvPr id="1" name=""/>
+        <p:cNvGrpSpPr/>
+        <p:nvPr/>
+      </p:nvGrpSpPr>
+      <p:grpSpPr>
+        <a:xfrm>
+          <a:off x="0" y="0"/>
+          <a:ext cx="0" cy="0"/>
+          <a:chOff x="0" y="0"/>
+          <a:chExt cx="0" cy="0"/>
+        </a:xfrm>
+      </p:grpSpPr>
+      <p:sp>
+        <p:nvSpPr>
+          <p:cNvPr id="2" name="Slide Image Placeholder 1"/>
+          <p:cNvSpPr>
+            <a:spLocks noGrp="1" noRot="1" noChangeAspect="1"/>
+          </p:cNvSpPr>
+          <p:nvPr>
+            <p:ph type="sldImg"/>
+          </p:nvPr>
+        </p:nvSpPr>
+        <p:spPr/>
+      </p:sp>
+      <p:sp>
+        <p:nvSpPr>
+          <p:cNvPr id="3" name="Notes Placeholder 2"/>
+          <p:cNvSpPr>
+            <a:spLocks noGrp="1"/>
+          </p:cNvSpPr>
+          <p:nvPr>
+            <p:ph type="body" idx="1"/>
+          </p:nvPr>
+        </p:nvSpPr>
+        <p:spPr/>
+        <p:txBody>
+          <a:bodyPr/>
+          <a:lstStyle/>
+          <a:p>
+            <a:endParaRPr lang="en-US" dirty="0"/>
+          </a:p>
+        </p:txBody>
+      </p:sp>
+      <p:sp>
+        <p:nvSpPr>
+          <p:cNvPr id="4" name="Slide Number Placeholder 3"/>
+          <p:cNvSpPr>
+            <a:spLocks noGrp="1"/>
+          </p:cNvSpPr>
+          <p:nvPr>
+            <p:ph type="sldNum" sz="quarter" idx="10"/>
+          </p:nvPr>
+        </p:nvSpPr>
+        <p:spPr/>
+        <p:txBody>
+          <a:bodyPr/>
+          <a:lstStyle/>
+          <a:p>
+            <a:fld id="{F7021451-1387-4CA6-816F-3879F97B5CBC}" type="slidenum">
+              <a:rPr lang="en-US"/>
+              <a:t>12</a:t>
+            </a:fld>
+            <a:endParaRPr lang="en-US"/>
+          </a:p>
+        </p:txBody>
+      </p:sp>
+    </p:spTree>
+    <p:extLst>
+      <p:ext uri="{BB962C8B-B14F-4D97-AF65-F5344CB8AC3E}">
+        <p14:creationId xmlns:p14="http://schemas.microsoft.com/office/powerpoint/2010/main" val="1024086991"/>
+      </p:ext>
+    </p:extLst>
+  </p:cSld>
+  <p:clrMapOvr>
+    <a:masterClrMapping/>
+  </p:clrMapOvr>
+</p:notes>
+</file>
+
+<file path=ppt/notesSlides/notesSlide12.xml><?xml version="1.0" encoding="utf-8"?>
+<p:notes xmlns:a="http://schemas.openxmlformats.org/drawingml/2006/main" xmlns:r="http://schemas.openxmlformats.org/officeDocument/2006/relationships" xmlns:p="http://schemas.openxmlformats.org/presentationml/2006/main">
+  <p:cSld>
+    <p:spTree>
+      <p:nvGrpSpPr>
+        <p:cNvPr id="1" name=""/>
+        <p:cNvGrpSpPr/>
+        <p:nvPr/>
+      </p:nvGrpSpPr>
+      <p:grpSpPr>
+        <a:xfrm>
+          <a:off x="0" y="0"/>
+          <a:ext cx="0" cy="0"/>
+          <a:chOff x="0" y="0"/>
+          <a:chExt cx="0" cy="0"/>
+        </a:xfrm>
+      </p:grpSpPr>
+      <p:sp>
+        <p:nvSpPr>
+          <p:cNvPr id="2" name="Slide Image Placeholder 1"/>
+          <p:cNvSpPr>
+            <a:spLocks noGrp="1" noRot="1" noChangeAspect="1"/>
+          </p:cNvSpPr>
+          <p:nvPr>
+            <p:ph type="sldImg"/>
+          </p:nvPr>
+        </p:nvSpPr>
+        <p:spPr/>
+      </p:sp>
+      <p:sp>
+        <p:nvSpPr>
+          <p:cNvPr id="3" name="Notes Placeholder 2"/>
+          <p:cNvSpPr>
+            <a:spLocks noGrp="1"/>
+          </p:cNvSpPr>
+          <p:nvPr>
+            <p:ph type="body" idx="1"/>
+          </p:nvPr>
+        </p:nvSpPr>
+        <p:spPr/>
+        <p:txBody>
+          <a:bodyPr/>
+          <a:lstStyle/>
+          <a:p>
+            <a:endParaRPr lang="en-US" dirty="0"/>
+          </a:p>
+        </p:txBody>
+      </p:sp>
+      <p:sp>
+        <p:nvSpPr>
+          <p:cNvPr id="4" name="Slide Number Placeholder 3"/>
+          <p:cNvSpPr>
+            <a:spLocks noGrp="1"/>
+          </p:cNvSpPr>
+          <p:nvPr>
+            <p:ph type="sldNum" sz="quarter" idx="10"/>
+          </p:nvPr>
+        </p:nvSpPr>
+        <p:spPr/>
+        <p:txBody>
+          <a:bodyPr/>
+          <a:lstStyle/>
+          <a:p>
+            <a:fld id="{F7021451-1387-4CA6-816F-3879F97B5CBC}" type="slidenum">
+              <a:rPr lang="en-US"/>
+              <a:t>13</a:t>
+            </a:fld>
+            <a:endParaRPr lang="en-US"/>
+          </a:p>
+        </p:txBody>
+      </p:sp>
+    </p:spTree>
+    <p:extLst>
+      <p:ext uri="{BB962C8B-B14F-4D97-AF65-F5344CB8AC3E}">
+        <p14:creationId xmlns:p14="http://schemas.microsoft.com/office/powerpoint/2010/main" val="1024086991"/>
+      </p:ext>
+    </p:extLst>
+  </p:cSld>
+  <p:clrMapOvr>
+    <a:masterClrMapping/>
+  </p:clrMapOvr>
+</p:notes>
+</file>
+
+<file path=ppt/notesSlides/notesSlide13.xml><?xml version="1.0" encoding="utf-8"?>
+<p:notes xmlns:a="http://schemas.openxmlformats.org/drawingml/2006/main" xmlns:r="http://schemas.openxmlformats.org/officeDocument/2006/relationships" xmlns:p="http://schemas.openxmlformats.org/presentationml/2006/main">
+  <p:cSld>
+    <p:spTree>
+      <p:nvGrpSpPr>
+        <p:cNvPr id="1" name=""/>
+        <p:cNvGrpSpPr/>
+        <p:nvPr/>
+      </p:nvGrpSpPr>
+      <p:grpSpPr>
+        <a:xfrm>
+          <a:off x="0" y="0"/>
+          <a:ext cx="0" cy="0"/>
+          <a:chOff x="0" y="0"/>
+          <a:chExt cx="0" cy="0"/>
+        </a:xfrm>
+      </p:grpSpPr>
+      <p:sp>
+        <p:nvSpPr>
+          <p:cNvPr id="2" name="Slide Image Placeholder 1"/>
+          <p:cNvSpPr>
+            <a:spLocks noGrp="1" noRot="1" noChangeAspect="1"/>
+          </p:cNvSpPr>
+          <p:nvPr>
+            <p:ph type="sldImg"/>
+          </p:nvPr>
+        </p:nvSpPr>
+        <p:spPr/>
+      </p:sp>
+      <p:sp>
+        <p:nvSpPr>
+          <p:cNvPr id="3" name="Notes Placeholder 2"/>
+          <p:cNvSpPr>
+            <a:spLocks noGrp="1"/>
+          </p:cNvSpPr>
+          <p:nvPr>
+            <p:ph type="body" idx="1"/>
+          </p:nvPr>
+        </p:nvSpPr>
+        <p:spPr/>
+        <p:txBody>
+          <a:bodyPr/>
+          <a:lstStyle/>
+          <a:p>
+            <a:endParaRPr lang="en-US" dirty="0"/>
+          </a:p>
+        </p:txBody>
+      </p:sp>
+      <p:sp>
+        <p:nvSpPr>
+          <p:cNvPr id="4" name="Slide Number Placeholder 3"/>
+          <p:cNvSpPr>
+            <a:spLocks noGrp="1"/>
+          </p:cNvSpPr>
+          <p:nvPr>
+            <p:ph type="sldNum" sz="quarter" idx="10"/>
+          </p:nvPr>
+        </p:nvSpPr>
+        <p:spPr/>
+        <p:txBody>
+          <a:bodyPr/>
+          <a:lstStyle/>
+          <a:p>
+            <a:fld id="{F7021451-1387-4CA6-816F-3879F97B5CBC}" type="slidenum">
+              <a:rPr lang="en-US"/>
+              <a:t>14</a:t>
+            </a:fld>
+            <a:endParaRPr lang="en-US"/>
+          </a:p>
+        </p:txBody>
+      </p:sp>
+    </p:spTree>
+    <p:extLst>
+      <p:ext uri="{BB962C8B-B14F-4D97-AF65-F5344CB8AC3E}">
+        <p14:creationId xmlns:p14="http://schemas.microsoft.com/office/powerpoint/2010/main" val="1024086991"/>
+      </p:ext>
+    </p:extLst>
+  </p:cSld>
+  <p:clrMapOvr>
+    <a:masterClrMapping/>
+  </p:clrMapOvr>
+</p:notes>
+</file>
+
+<file path=ppt/notesSlides/notesSlide2.xml><?xml version="1.0" encoding="utf-8"?>
+<p:notes xmlns:a="http://schemas.openxmlformats.org/drawingml/2006/main" xmlns:r="http://schemas.openxmlformats.org/officeDocument/2006/relationships" xmlns:p="http://schemas.openxmlformats.org/presentationml/2006/main">
+  <p:cSld>
+    <p:spTree>
+      <p:nvGrpSpPr>
+        <p:cNvPr id="1" name=""/>
+        <p:cNvGrpSpPr/>
+        <p:nvPr/>
+      </p:nvGrpSpPr>
+      <p:grpSpPr>
+        <a:xfrm>
+          <a:off x="0" y="0"/>
+          <a:ext cx="0" cy="0"/>
+          <a:chOff x="0" y="0"/>
+          <a:chExt cx="0" cy="0"/>
+        </a:xfrm>
+      </p:grpSpPr>
+      <p:sp>
+        <p:nvSpPr>
+          <p:cNvPr id="2" name="Slide Image Placeholder 1"/>
+          <p:cNvSpPr>
+            <a:spLocks noGrp="1" noRot="1" noChangeAspect="1"/>
+          </p:cNvSpPr>
+          <p:nvPr>
+            <p:ph type="sldImg"/>
+          </p:nvPr>
+        </p:nvSpPr>
+        <p:spPr/>
+      </p:sp>
+      <p:sp>
+        <p:nvSpPr>
+          <p:cNvPr id="3" name="Notes Placeholder 2"/>
+          <p:cNvSpPr>
+            <a:spLocks noGrp="1"/>
+          </p:cNvSpPr>
+          <p:nvPr>
+            <p:ph type="body" idx="1"/>
+          </p:nvPr>
+        </p:nvSpPr>
+        <p:spPr/>
+        <p:txBody>
+          <a:bodyPr/>
+          <a:lstStyle/>
+          <a:p>
+            <a:endParaRPr lang="en-US" dirty="0"/>
+          </a:p>
+        </p:txBody>
+      </p:sp>
+      <p:sp>
+        <p:nvSpPr>
+          <p:cNvPr id="4" name="Slide Number Placeholder 3"/>
+          <p:cNvSpPr>
+            <a:spLocks noGrp="1"/>
+          </p:cNvSpPr>
+          <p:nvPr>
+            <p:ph type="sldNum" sz="quarter" idx="10"/>
+          </p:nvPr>
+        </p:nvSpPr>
+        <p:spPr/>
+        <p:txBody>
+          <a:bodyPr/>
+          <a:lstStyle/>
+          <a:p>
+            <a:fld id="{F7021451-1387-4CA6-816F-3879F97B5CBC}" type="slidenum">
+              <a:rPr lang="en-US"/>
+              <a:t>2</a:t>
+            </a:fld>
+            <a:endParaRPr lang="en-US"/>
+          </a:p>
+        </p:txBody>
+      </p:sp>
+    </p:spTree>
+    <p:extLst>
+      <p:ext uri="{BB962C8B-B14F-4D97-AF65-F5344CB8AC3E}">
+        <p14:creationId xmlns:p14="http://schemas.microsoft.com/office/powerpoint/2010/main" val="1024086991"/>
+      </p:ext>
+    </p:extLst>
+  </p:cSld>
+  <p:clrMapOvr>
+    <a:masterClrMapping/>
+  </p:clrMapOvr>
+</p:notes>
+</file>
+
+<file path=ppt/notesSlides/notesSlide3.xml><?xml version="1.0" encoding="utf-8"?>
+<p:notes xmlns:a="http://schemas.openxmlformats.org/drawingml/2006/main" xmlns:r="http://schemas.openxmlformats.org/officeDocument/2006/relationships" xmlns:p="http://schemas.openxmlformats.org/presentationml/2006/main">
+  <p:cSld>
+    <p:spTree>
+      <p:nvGrpSpPr>
+        <p:cNvPr id="1" name=""/>
+        <p:cNvGrpSpPr/>
+        <p:nvPr/>
+      </p:nvGrpSpPr>
+      <p:grpSpPr>
+        <a:xfrm>
+          <a:off x="0" y="0"/>
+          <a:ext cx="0" cy="0"/>
+          <a:chOff x="0" y="0"/>
+          <a:chExt cx="0" cy="0"/>
+        </a:xfrm>
+      </p:grpSpPr>
+      <p:sp>
+        <p:nvSpPr>
+          <p:cNvPr id="2" name="Slide Image Placeholder 1"/>
+          <p:cNvSpPr>
+            <a:spLocks noGrp="1" noRot="1" noChangeAspect="1"/>
+          </p:cNvSpPr>
+          <p:nvPr>
+            <p:ph type="sldImg"/>
+          </p:nvPr>
+        </p:nvSpPr>
+        <p:spPr/>
+      </p:sp>
+      <p:sp>
+        <p:nvSpPr>
+          <p:cNvPr id="3" name="Notes Placeholder 2"/>
+          <p:cNvSpPr>
+            <a:spLocks noGrp="1"/>
+          </p:cNvSpPr>
+          <p:nvPr>
+            <p:ph type="body" idx="1"/>
+          </p:nvPr>
+        </p:nvSpPr>
+        <p:spPr/>
+        <p:txBody>
+          <a:bodyPr/>
+          <a:lstStyle/>
+          <a:p>
+            <a:endParaRPr lang="en-US" dirty="0"/>
+          </a:p>
+        </p:txBody>
+      </p:sp>
+      <p:sp>
+        <p:nvSpPr>
+          <p:cNvPr id="4" name="Slide Number Placeholder 3"/>
+          <p:cNvSpPr>
+            <a:spLocks noGrp="1"/>
+          </p:cNvSpPr>
+          <p:nvPr>
+            <p:ph type="sldNum" sz="quarter" idx="10"/>
+          </p:nvPr>
+        </p:nvSpPr>
+        <p:spPr/>
+        <p:txBody>
+          <a:bodyPr/>
+          <a:lstStyle/>
+          <a:p>
+            <a:fld id="{F7021451-1387-4CA6-816F-3879F97B5CBC}" type="slidenum">
+              <a:rPr lang="en-US"/>
+              <a:t>3</a:t>
+            </a:fld>
+            <a:endParaRPr lang="en-US"/>
+          </a:p>
+        </p:txBody>
+      </p:sp>
+    </p:spTree>
+    <p:extLst>
+      <p:ext uri="{BB962C8B-B14F-4D97-AF65-F5344CB8AC3E}">
+        <p14:creationId xmlns:p14="http://schemas.microsoft.com/office/powerpoint/2010/main" val="1024086991"/>
+      </p:ext>
+    </p:extLst>
+  </p:cSld>
+  <p:clrMapOvr>
+    <a:masterClrMapping/>
+  </p:clrMapOvr>
+</p:notes>
+</file>
+
+<file path=ppt/notesSlides/notesSlide4.xml><?xml version="1.0" encoding="utf-8"?>
+<p:notes xmlns:a="http://schemas.openxmlformats.org/drawingml/2006/main" xmlns:r="http://schemas.openxmlformats.org/officeDocument/2006/relationships" xmlns:p="http://schemas.openxmlformats.org/presentationml/2006/main">
+  <p:cSld>
+    <p:spTree>
+      <p:nvGrpSpPr>
+        <p:cNvPr id="1" name=""/>
+        <p:cNvGrpSpPr/>
+        <p:nvPr/>
+      </p:nvGrpSpPr>
+      <p:grpSpPr>
+        <a:xfrm>
+          <a:off x="0" y="0"/>
+          <a:ext cx="0" cy="0"/>
+          <a:chOff x="0" y="0"/>
+          <a:chExt cx="0" cy="0"/>
+        </a:xfrm>
+      </p:grpSpPr>
+      <p:sp>
+        <p:nvSpPr>
+          <p:cNvPr id="2" name="Slide Image Placeholder 1"/>
+          <p:cNvSpPr>
+            <a:spLocks noGrp="1" noRot="1" noChangeAspect="1"/>
+          </p:cNvSpPr>
+          <p:nvPr>
+            <p:ph type="sldImg"/>
+          </p:nvPr>
+        </p:nvSpPr>
+        <p:spPr/>
+      </p:sp>
+      <p:sp>
+        <p:nvSpPr>
+          <p:cNvPr id="3" name="Notes Placeholder 2"/>
+          <p:cNvSpPr>
+            <a:spLocks noGrp="1"/>
+          </p:cNvSpPr>
+          <p:nvPr>
+            <p:ph type="body" idx="1"/>
+          </p:nvPr>
+        </p:nvSpPr>
+        <p:spPr/>
+        <p:txBody>
+          <a:bodyPr/>
+          <a:lstStyle/>
+          <a:p>
+            <a:endParaRPr lang="en-US" dirty="0"/>
+          </a:p>
+        </p:txBody>
+      </p:sp>
+      <p:sp>
+        <p:nvSpPr>
+          <p:cNvPr id="4" name="Slide Number Placeholder 3"/>
+          <p:cNvSpPr>
+            <a:spLocks noGrp="1"/>
+          </p:cNvSpPr>
+          <p:nvPr>
+            <p:ph type="sldNum" sz="quarter" idx="10"/>
+          </p:nvPr>
+        </p:nvSpPr>
+        <p:spPr/>
+        <p:txBody>
+          <a:bodyPr/>
+          <a:lstStyle/>
+          <a:p>
+            <a:fld id="{F7021451-1387-4CA6-816F-3879F97B5CBC}" type="slidenum">
+              <a:rPr lang="en-US"/>
+              <a:t>4</a:t>
+            </a:fld>
+            <a:endParaRPr lang="en-US"/>
+          </a:p>
+        </p:txBody>
+      </p:sp>
+    </p:spTree>
+    <p:extLst>
+      <p:ext uri="{BB962C8B-B14F-4D97-AF65-F5344CB8AC3E}">
+        <p14:creationId xmlns:p14="http://schemas.microsoft.com/office/powerpoint/2010/main" val="1024086991"/>
+      </p:ext>
+    </p:extLst>
+  </p:cSld>
+  <p:clrMapOvr>
+    <a:masterClrMapping/>
+  </p:clrMapOvr>
+</p:notes>
+</file>
+
+<file path=ppt/notesSlides/notesSlide5.xml><?xml version="1.0" encoding="utf-8"?>
+<p:notes xmlns:a="http://schemas.openxmlformats.org/drawingml/2006/main" xmlns:r="http://schemas.openxmlformats.org/officeDocument/2006/relationships" xmlns:p="http://schemas.openxmlformats.org/presentationml/2006/main">
+  <p:cSld>
+    <p:spTree>
+      <p:nvGrpSpPr>
+        <p:cNvPr id="1" name=""/>
+        <p:cNvGrpSpPr/>
+        <p:nvPr/>
+      </p:nvGrpSpPr>
+      <p:grpSpPr>
+        <a:xfrm>
+          <a:off x="0" y="0"/>
+          <a:ext cx="0" cy="0"/>
+          <a:chOff x="0" y="0"/>
+          <a:chExt cx="0" cy="0"/>
+        </a:xfrm>
+      </p:grpSpPr>
+      <p:sp>
+        <p:nvSpPr>
+          <p:cNvPr id="2" name="Slide Image Placeholder 1"/>
+          <p:cNvSpPr>
+            <a:spLocks noGrp="1" noRot="1" noChangeAspect="1"/>
+          </p:cNvSpPr>
+          <p:nvPr>
+            <p:ph type="sldImg"/>
+          </p:nvPr>
+        </p:nvSpPr>
+        <p:spPr/>
+      </p:sp>
+      <p:sp>
+        <p:nvSpPr>
+          <p:cNvPr id="3" name="Notes Placeholder 2"/>
+          <p:cNvSpPr>
+            <a:spLocks noGrp="1"/>
+          </p:cNvSpPr>
+          <p:nvPr>
+            <p:ph type="body" idx="1"/>
+          </p:nvPr>
+        </p:nvSpPr>
+        <p:spPr/>
+        <p:txBody>
+          <a:bodyPr/>
+          <a:lstStyle/>
+          <a:p>
+            <a:endParaRPr lang="en-US" dirty="0"/>
+          </a:p>
+        </p:txBody>
+      </p:sp>
+      <p:sp>
+        <p:nvSpPr>
+          <p:cNvPr id="4" name="Slide Number Placeholder 3"/>
+          <p:cNvSpPr>
+            <a:spLocks noGrp="1"/>
+          </p:cNvSpPr>
+          <p:nvPr>
+            <p:ph type="sldNum" sz="quarter" idx="10"/>
+          </p:nvPr>
+        </p:nvSpPr>
+        <p:spPr/>
+        <p:txBody>
+          <a:bodyPr/>
+          <a:lstStyle/>
+          <a:p>
+            <a:fld id="{F7021451-1387-4CA6-816F-3879F97B5CBC}" type="slidenum">
+              <a:rPr lang="en-US"/>
+              <a:t>5</a:t>
+            </a:fld>
+            <a:endParaRPr lang="en-US"/>
+          </a:p>
+        </p:txBody>
+      </p:sp>
+    </p:spTree>
+    <p:extLst>
+      <p:ext uri="{BB962C8B-B14F-4D97-AF65-F5344CB8AC3E}">
+        <p14:creationId xmlns:p14="http://schemas.microsoft.com/office/powerpoint/2010/main" val="1024086991"/>
+      </p:ext>
+    </p:extLst>
+  </p:cSld>
+  <p:clrMapOvr>
+    <a:masterClrMapping/>
+  </p:clrMapOvr>
+</p:notes>
+</file>
+
+<file path=ppt/notesSlides/notesSlide6.xml><?xml version="1.0" encoding="utf-8"?>
+<p:notes xmlns:a="http://schemas.openxmlformats.org/drawingml/2006/main" xmlns:r="http://schemas.openxmlformats.org/officeDocument/2006/relationships" xmlns:p="http://schemas.openxmlformats.org/presentationml/2006/main">
+  <p:cSld>
+    <p:spTree>
+      <p:nvGrpSpPr>
+        <p:cNvPr id="1" name=""/>
+        <p:cNvGrpSpPr/>
+        <p:nvPr/>
+      </p:nvGrpSpPr>
+      <p:grpSpPr>
+        <a:xfrm>
+          <a:off x="0" y="0"/>
+          <a:ext cx="0" cy="0"/>
+          <a:chOff x="0" y="0"/>
+          <a:chExt cx="0" cy="0"/>
+        </a:xfrm>
+      </p:grpSpPr>
+      <p:sp>
+        <p:nvSpPr>
+          <p:cNvPr id="2" name="Slide Image Placeholder 1"/>
+          <p:cNvSpPr>
+            <a:spLocks noGrp="1" noRot="1" noChangeAspect="1"/>
+          </p:cNvSpPr>
+          <p:nvPr>
+            <p:ph type="sldImg"/>
+          </p:nvPr>
+        </p:nvSpPr>
+        <p:spPr/>
+      </p:sp>
+      <p:sp>
+        <p:nvSpPr>
+          <p:cNvPr id="3" name="Notes Placeholder 2"/>
+          <p:cNvSpPr>
+            <a:spLocks noGrp="1"/>
+          </p:cNvSpPr>
+          <p:nvPr>
+            <p:ph type="body" idx="1"/>
+          </p:nvPr>
+        </p:nvSpPr>
+        <p:spPr/>
+        <p:txBody>
+          <a:bodyPr/>
+          <a:lstStyle/>
+          <a:p>
+            <a:endParaRPr lang="en-US" dirty="0"/>
+          </a:p>
+        </p:txBody>
+      </p:sp>
+      <p:sp>
+        <p:nvSpPr>
+          <p:cNvPr id="4" name="Slide Number Placeholder 3"/>
+          <p:cNvSpPr>
+            <a:spLocks noGrp="1"/>
+          </p:cNvSpPr>
+          <p:nvPr>
+            <p:ph type="sldNum" sz="quarter" idx="10"/>
+          </p:nvPr>
+        </p:nvSpPr>
+        <p:spPr/>
+        <p:txBody>
+          <a:bodyPr/>
+          <a:lstStyle/>
+          <a:p>
+            <a:fld id="{F7021451-1387-4CA6-816F-3879F97B5CBC}" type="slidenum">
+              <a:rPr lang="en-US"/>
+              <a:t>6</a:t>
+            </a:fld>
+            <a:endParaRPr lang="en-US"/>
+          </a:p>
+        </p:txBody>
+      </p:sp>
+    </p:spTree>
+    <p:extLst>
+      <p:ext uri="{BB962C8B-B14F-4D97-AF65-F5344CB8AC3E}">
+        <p14:creationId xmlns:p14="http://schemas.microsoft.com/office/powerpoint/2010/main" val="1024086991"/>
+      </p:ext>
+    </p:extLst>
+  </p:cSld>
+  <p:clrMapOvr>
+    <a:masterClrMapping/>
+  </p:clrMapOvr>
+</p:notes>
+</file>
+
+<file path=ppt/notesSlides/notesSlide7.xml><?xml version="1.0" encoding="utf-8"?>
+<p:notes xmlns:a="http://schemas.openxmlformats.org/drawingml/2006/main" xmlns:r="http://schemas.openxmlformats.org/officeDocument/2006/relationships" xmlns:p="http://schemas.openxmlformats.org/presentationml/2006/main">
+  <p:cSld>
+    <p:spTree>
+      <p:nvGrpSpPr>
+        <p:cNvPr id="1" name=""/>
+        <p:cNvGrpSpPr/>
+        <p:nvPr/>
+      </p:nvGrpSpPr>
+      <p:grpSpPr>
+        <a:xfrm>
+          <a:off x="0" y="0"/>
+          <a:ext cx="0" cy="0"/>
+          <a:chOff x="0" y="0"/>
+          <a:chExt cx="0" cy="0"/>
+        </a:xfrm>
+      </p:grpSpPr>
+      <p:sp>
+        <p:nvSpPr>
+          <p:cNvPr id="2" name="Slide Image Placeholder 1"/>
+          <p:cNvSpPr>
+            <a:spLocks noGrp="1" noRot="1" noChangeAspect="1"/>
+          </p:cNvSpPr>
+          <p:nvPr>
+            <p:ph type="sldImg"/>
+          </p:nvPr>
+        </p:nvSpPr>
+        <p:spPr/>
+      </p:sp>
+      <p:sp>
+        <p:nvSpPr>
+          <p:cNvPr id="3" name="Notes Placeholder 2"/>
+          <p:cNvSpPr>
+            <a:spLocks noGrp="1"/>
+          </p:cNvSpPr>
+          <p:nvPr>
+            <p:ph type="body" idx="1"/>
+          </p:nvPr>
+        </p:nvSpPr>
+        <p:spPr/>
+        <p:txBody>
+          <a:bodyPr/>
+          <a:lstStyle/>
+          <a:p>
+            <a:endParaRPr lang="en-US" dirty="0"/>
+          </a:p>
+        </p:txBody>
+      </p:sp>
+      <p:sp>
+        <p:nvSpPr>
+          <p:cNvPr id="4" name="Slide Number Placeholder 3"/>
+          <p:cNvSpPr>
+            <a:spLocks noGrp="1"/>
+          </p:cNvSpPr>
+          <p:nvPr>
+            <p:ph type="sldNum" sz="quarter" idx="10"/>
+          </p:nvPr>
+        </p:nvSpPr>
+        <p:spPr/>
+        <p:txBody>
+          <a:bodyPr/>
+          <a:lstStyle/>
+          <a:p>
+            <a:fld id="{F7021451-1387-4CA6-816F-3879F97B5CBC}" type="slidenum">
+              <a:rPr lang="en-US"/>
+              <a:t>7</a:t>
+            </a:fld>
+            <a:endParaRPr lang="en-US"/>
+          </a:p>
+        </p:txBody>
+      </p:sp>
+    </p:spTree>
+    <p:extLst>
+      <p:ext uri="{BB962C8B-B14F-4D97-AF65-F5344CB8AC3E}">
+        <p14:creationId xmlns:p14="http://schemas.microsoft.com/office/powerpoint/2010/main" val="1024086991"/>
+      </p:ext>
+    </p:extLst>
+  </p:cSld>
+  <p:clrMapOvr>
+    <a:masterClrMapping/>
+  </p:clrMapOvr>
+</p:notes>
+</file>
+
+<file path=ppt/notesSlides/notesSlide8.xml><?xml version="1.0" encoding="utf-8"?>
+<p:notes xmlns:a="http://schemas.openxmlformats.org/drawingml/2006/main" xmlns:r="http://schemas.openxmlformats.org/officeDocument/2006/relationships" xmlns:p="http://schemas.openxmlformats.org/presentationml/2006/main">
+  <p:cSld>
+    <p:spTree>
+      <p:nvGrpSpPr>
+        <p:cNvPr id="1" name=""/>
+        <p:cNvGrpSpPr/>
+        <p:nvPr/>
+      </p:nvGrpSpPr>
+      <p:grpSpPr>
+        <a:xfrm>
+          <a:off x="0" y="0"/>
+          <a:ext cx="0" cy="0"/>
+          <a:chOff x="0" y="0"/>
+          <a:chExt cx="0" cy="0"/>
+        </a:xfrm>
+      </p:grpSpPr>
+      <p:sp>
+        <p:nvSpPr>
+          <p:cNvPr id="2" name="Slide Image Placeholder 1"/>
+          <p:cNvSpPr>
+            <a:spLocks noGrp="1" noRot="1" noChangeAspect="1"/>
+          </p:cNvSpPr>
+          <p:nvPr>
+            <p:ph type="sldImg"/>
+          </p:nvPr>
+        </p:nvSpPr>
+        <p:spPr/>
+      </p:sp>
+      <p:sp>
+        <p:nvSpPr>
+          <p:cNvPr id="3" name="Notes Placeholder 2"/>
+          <p:cNvSpPr>
+            <a:spLocks noGrp="1"/>
+          </p:cNvSpPr>
+          <p:nvPr>
+            <p:ph type="body" idx="1"/>
+          </p:nvPr>
+        </p:nvSpPr>
+        <p:spPr/>
+        <p:txBody>
+          <a:bodyPr/>
+          <a:lstStyle/>
+          <a:p>
+            <a:endParaRPr lang="en-US" dirty="0"/>
+          </a:p>
+        </p:txBody>
+      </p:sp>
+      <p:sp>
+        <p:nvSpPr>
+          <p:cNvPr id="4" name="Slide Number Placeholder 3"/>
+          <p:cNvSpPr>
+            <a:spLocks noGrp="1"/>
+          </p:cNvSpPr>
+          <p:nvPr>
+            <p:ph type="sldNum" sz="quarter" idx="10"/>
+          </p:nvPr>
+        </p:nvSpPr>
+        <p:spPr/>
+        <p:txBody>
+          <a:bodyPr/>
+          <a:lstStyle/>
+          <a:p>
+            <a:fld id="{F7021451-1387-4CA6-816F-3879F97B5CBC}" type="slidenum">
+              <a:rPr lang="en-US"/>
+              <a:t>8</a:t>
+            </a:fld>
+            <a:endParaRPr lang="en-US"/>
+          </a:p>
+        </p:txBody>
+      </p:sp>
+    </p:spTree>
+    <p:extLst>
+      <p:ext uri="{BB962C8B-B14F-4D97-AF65-F5344CB8AC3E}">
+        <p14:creationId xmlns:p14="http://schemas.microsoft.com/office/powerpoint/2010/main" val="1024086991"/>
+      </p:ext>
+    </p:extLst>
+  </p:cSld>
+  <p:clrMapOvr>
+    <a:masterClrMapping/>
+  </p:clrMapOvr>
+</p:notes>
+</file>
+
+<file path=ppt/notesSlides/notesSlide9.xml><?xml version="1.0" encoding="utf-8"?>
+<p:notes xmlns:a="http://schemas.openxmlformats.org/drawingml/2006/main" xmlns:r="http://schemas.openxmlformats.org/officeDocument/2006/relationships" xmlns:p="http://schemas.openxmlformats.org/presentationml/2006/main">
+  <p:cSld>
+    <p:spTree>
+      <p:nvGrpSpPr>
+        <p:cNvPr id="1" name=""/>
+        <p:cNvGrpSpPr/>
+        <p:nvPr/>
+      </p:nvGrpSpPr>
+      <p:grpSpPr>
+        <a:xfrm>
+          <a:off x="0" y="0"/>
+          <a:ext cx="0" cy="0"/>
+          <a:chOff x="0" y="0"/>
+          <a:chExt cx="0" cy="0"/>
+        </a:xfrm>
+      </p:grpSpPr>
+      <p:sp>
+        <p:nvSpPr>
+          <p:cNvPr id="2" name="Slide Image Placeholder 1"/>
+          <p:cNvSpPr>
+            <a:spLocks noGrp="1" noRot="1" noChangeAspect="1"/>
+          </p:cNvSpPr>
+          <p:nvPr>
+            <p:ph type="sldImg"/>
+          </p:nvPr>
+        </p:nvSpPr>
+        <p:spPr/>
+      </p:sp>
+      <p:sp>
+        <p:nvSpPr>
+          <p:cNvPr id="3" name="Notes Placeholder 2"/>
+          <p:cNvSpPr>
+            <a:spLocks noGrp="1"/>
+          </p:cNvSpPr>
+          <p:nvPr>
+            <p:ph type="body" idx="1"/>
+          </p:nvPr>
+        </p:nvSpPr>
+        <p:spPr/>
+        <p:txBody>
+          <a:bodyPr/>
+          <a:lstStyle/>
+          <a:p>
+            <a:endParaRPr lang="en-US" dirty="0"/>
+          </a:p>
+        </p:txBody>
+      </p:sp>
+      <p:sp>
+        <p:nvSpPr>
+          <p:cNvPr id="4" name="Slide Number Placeholder 3"/>
+          <p:cNvSpPr>
+            <a:spLocks noGrp="1"/>
+          </p:cNvSpPr>
+          <p:nvPr>
+            <p:ph type="sldNum" sz="quarter" idx="10"/>
+          </p:nvPr>
+        </p:nvSpPr>
+        <p:spPr/>
+        <p:txBody>
+          <a:bodyPr/>
+          <a:lstStyle/>
+          <a:p>
+            <a:fld id="{F7021451-1387-4CA6-816F-3879F97B5CBC}" type="slidenum">
+              <a:rPr lang="en-US"/>
+              <a:t>10</a:t>
+            </a:fld>
+            <a:endParaRPr lang="en-US"/>
+          </a:p>
+        </p:txBody>
+      </p:sp>
+    </p:spTree>
+    <p:extLst>
+      <p:ext uri="{BB962C8B-B14F-4D97-AF65-F5344CB8AC3E}">
+        <p14:creationId xmlns:p14="http://schemas.microsoft.com/office/powerpoint/2010/main" val="1024086991"/>
+      </p:ext>
+    </p:extLst>
+  </p:cSld>
+  <p:clrMapOvr>
+    <a:masterClrMapping/>
+  </p:clrMapOvr>
+</p:notes>
 </file>
 
 <file path=ppt/slideLayouts/slideLayout1.xml><?xml version="1.0" encoding="utf-8"?>
@@ -524,7 +1745,7 @@
           <p:nvPr/>
         </p:nvPicPr>
         <p:blipFill>
-          <a:blip r:embed="rId2"/>
+          <a:blip r:embed="rId3"/>
           <a:stretch>
             <a:fillRect/>
           </a:stretch>
@@ -706,6 +1927,45 @@
               <a:t>90 min  ·  40 lecture / demo  +  50 lab</a:t>
             </a:r>
             <a:endParaRPr lang="en-US" sz="1700" dirty="0"/>
+          </a:p>
+        </p:txBody>
+      </p:sp>
+      <p:sp>
+        <p:nvSpPr>
+          <p:cNvPr id="9" name="Text 6"/>
+          <p:cNvSpPr/>
+          <p:nvPr/>
+        </p:nvSpPr>
+        <p:spPr>
+          <a:xfrm>
+            <a:off x="640080" y="4462272"/>
+            <a:ext cx="8046720" cy="292608"/>
+          </a:xfrm>
+          <a:prstGeom prst="rect">
+            <a:avLst/>
+          </a:prstGeom>
+          <a:noFill/>
+          <a:ln/>
+        </p:spPr>
+        <p:txBody>
+          <a:bodyPr wrap="square" lIns="0" tIns="0" rIns="0" bIns="0" rtlCol="0" anchor="ctr"/>
+          <a:lstStyle/>
+          <a:p>
+            <a:pPr marL="0" indent="0">
+              <a:buNone/>
+            </a:pPr>
+            <a:r>
+              <a:rPr lang="en-US" sz="1000" i="1" dirty="0">
+                <a:solidFill>
+                  <a:srgbClr val="615C52"/>
+                </a:solidFill>
+                <a:latin typeface="Inter" pitchFamily="34" charset="0"/>
+                <a:ea typeface="Inter" pitchFamily="34" charset="-122"/>
+                <a:cs typeface="Inter" pitchFamily="34" charset="-120"/>
+              </a:rPr>
+              <a:t>dotnetclaude.com  ·  .NET AI with Claude Workshop</a:t>
+            </a:r>
+            <a:endParaRPr lang="en-US" sz="1000" dirty="0"/>
           </a:p>
         </p:txBody>
       </p:sp>
@@ -718,6 +1978,747 @@
 </file>
 
 <file path=ppt/slides/slide10.xml><?xml version="1.0" encoding="utf-8"?>
+<p:sld xmlns:a="http://schemas.openxmlformats.org/drawingml/2006/main" xmlns:r="http://schemas.openxmlformats.org/officeDocument/2006/relationships" xmlns:p="http://schemas.openxmlformats.org/presentationml/2006/main">
+  <p:cSld name="Slide 9">
+    <p:bg>
+      <p:bgPr>
+        <a:solidFill>
+          <a:srgbClr val="F0EEE6"/>
+        </a:solidFill>
+        <a:effectLst/>
+      </p:bgPr>
+    </p:bg>
+    <p:spTree>
+      <p:nvGrpSpPr>
+        <p:cNvPr id="1" name=""/>
+        <p:cNvGrpSpPr/>
+        <p:nvPr/>
+      </p:nvGrpSpPr>
+      <p:grpSpPr>
+        <a:xfrm>
+          <a:off x="0" y="0"/>
+          <a:ext cx="0" cy="0"/>
+          <a:chOff x="0" y="0"/>
+          <a:chExt cx="0" cy="0"/>
+        </a:xfrm>
+      </p:grpSpPr>
+      <p:sp>
+        <p:nvSpPr>
+          <p:cNvPr id="2" name="Text 0"/>
+          <p:cNvSpPr/>
+          <p:nvPr/>
+        </p:nvSpPr>
+        <p:spPr>
+          <a:xfrm>
+            <a:off x="548640" y="384048"/>
+            <a:ext cx="7132320" cy="274320"/>
+          </a:xfrm>
+          <a:prstGeom prst="rect">
+            <a:avLst/>
+          </a:prstGeom>
+          <a:noFill/>
+          <a:ln/>
+        </p:spPr>
+        <p:txBody>
+          <a:bodyPr wrap="square" lIns="0" tIns="0" rIns="0" bIns="0" rtlCol="0" anchor="ctr"/>
+          <a:lstStyle/>
+          <a:p>
+            <a:pPr marL="0" indent="0">
+              <a:buNone/>
+            </a:pPr>
+            <a:r>
+              <a:rPr lang="en-US" sz="1100" b="1" kern="0" spc="200" dirty="0">
+                <a:solidFill>
+                  <a:srgbClr val="D97757"/>
+                </a:solidFill>
+                <a:latin typeface="Inter" pitchFamily="34" charset="0"/>
+                <a:ea typeface="Inter" pitchFamily="34" charset="-122"/>
+                <a:cs typeface="Inter" pitchFamily="34" charset="-120"/>
+              </a:rPr>
+              <a:t>CLAUDE.MD BASICS</a:t>
+            </a:r>
+            <a:endParaRPr lang="en-US" sz="1100" dirty="0"/>
+          </a:p>
+        </p:txBody>
+      </p:sp>
+      <p:sp>
+        <p:nvSpPr>
+          <p:cNvPr id="3" name="Text 1"/>
+          <p:cNvSpPr/>
+          <p:nvPr/>
+        </p:nvSpPr>
+        <p:spPr>
+          <a:xfrm>
+            <a:off x="548640" y="640080"/>
+            <a:ext cx="8046720" cy="640080"/>
+          </a:xfrm>
+          <a:prstGeom prst="rect">
+            <a:avLst/>
+          </a:prstGeom>
+          <a:noFill/>
+          <a:ln/>
+        </p:spPr>
+        <p:txBody>
+          <a:bodyPr wrap="square" lIns="0" tIns="0" rIns="0" bIns="0" rtlCol="0" anchor="ctr"/>
+          <a:lstStyle/>
+          <a:p>
+            <a:pPr marL="0" indent="0">
+              <a:buNone/>
+            </a:pPr>
+            <a:r>
+              <a:rPr lang="en-US" sz="2700" b="1" dirty="0">
+                <a:solidFill>
+                  <a:srgbClr val="141413"/>
+                </a:solidFill>
+                <a:latin typeface="Georgia" pitchFamily="34" charset="0"/>
+                <a:ea typeface="Georgia" pitchFamily="34" charset="-122"/>
+                <a:cs typeface="Georgia" pitchFamily="34" charset="-120"/>
+              </a:rPr>
+              <a:t>Your project briefing (teaser)</a:t>
+            </a:r>
+            <a:endParaRPr lang="en-US" sz="2700" dirty="0"/>
+          </a:p>
+        </p:txBody>
+      </p:sp>
+      <p:pic>
+        <p:nvPicPr>
+          <p:cNvPr id="4" name="Image 0" descr="preencoded.png"/>
+          <p:cNvPicPr>
+            <a:picLocks noChangeAspect="1"/>
+          </p:cNvPicPr>
+          <p:nvPr/>
+        </p:nvPicPr>
+        <p:blipFill>
+          <a:blip r:embed="rId3"/>
+          <a:stretch>
+            <a:fillRect/>
+          </a:stretch>
+        </p:blipFill>
+        <p:spPr>
+          <a:xfrm>
+            <a:off x="8339328" y="411480"/>
+            <a:ext cx="292608" cy="292608"/>
+          </a:xfrm>
+          <a:prstGeom prst="rect">
+            <a:avLst/>
+          </a:prstGeom>
+        </p:spPr>
+      </p:pic>
+      <p:sp>
+        <p:nvSpPr>
+          <p:cNvPr id="5" name="Shape 2"/>
+          <p:cNvSpPr/>
+          <p:nvPr/>
+        </p:nvSpPr>
+        <p:spPr>
+          <a:xfrm>
+            <a:off x="548640" y="1508760"/>
+            <a:ext cx="8046720" cy="658368"/>
+          </a:xfrm>
+          <a:prstGeom prst="roundRect">
+            <a:avLst>
+              <a:gd name="adj" fmla="val 8333"/>
+            </a:avLst>
+          </a:prstGeom>
+          <a:solidFill>
+            <a:srgbClr val="FFFFFF"/>
+          </a:solidFill>
+          <a:ln w="12700">
+            <a:solidFill>
+              <a:srgbClr val="E4E1D6"/>
+            </a:solidFill>
+            <a:prstDash val="solid"/>
+          </a:ln>
+        </p:spPr>
+        <p:txBody>
+          <a:bodyPr/>
+          <a:lstStyle/>
+          <a:p>
+            <a:endParaRPr lang="en-US"/>
+          </a:p>
+        </p:txBody>
+      </p:sp>
+      <p:sp>
+        <p:nvSpPr>
+          <p:cNvPr id="6" name="Shape 3"/>
+          <p:cNvSpPr/>
+          <p:nvPr/>
+        </p:nvSpPr>
+        <p:spPr>
+          <a:xfrm>
+            <a:off x="749808" y="1627632"/>
+            <a:ext cx="420624" cy="420624"/>
+          </a:xfrm>
+          <a:prstGeom prst="ellipse">
+            <a:avLst/>
+          </a:prstGeom>
+          <a:solidFill>
+            <a:srgbClr val="D97757"/>
+          </a:solidFill>
+          <a:ln/>
+        </p:spPr>
+        <p:txBody>
+          <a:bodyPr/>
+          <a:lstStyle/>
+          <a:p>
+            <a:endParaRPr lang="en-US"/>
+          </a:p>
+        </p:txBody>
+      </p:sp>
+      <p:pic>
+        <p:nvPicPr>
+          <p:cNvPr id="7" name="Image 1" descr="preencoded.png"/>
+          <p:cNvPicPr>
+            <a:picLocks noChangeAspect="1"/>
+          </p:cNvPicPr>
+          <p:nvPr/>
+        </p:nvPicPr>
+        <p:blipFill>
+          <a:blip r:embed="rId4"/>
+          <a:stretch>
+            <a:fillRect/>
+          </a:stretch>
+        </p:blipFill>
+        <p:spPr>
+          <a:xfrm>
+            <a:off x="859170" y="1736994"/>
+            <a:ext cx="201900" cy="201900"/>
+          </a:xfrm>
+          <a:prstGeom prst="rect">
+            <a:avLst/>
+          </a:prstGeom>
+        </p:spPr>
+      </p:pic>
+      <p:sp>
+        <p:nvSpPr>
+          <p:cNvPr id="8" name="Text 4"/>
+          <p:cNvSpPr/>
+          <p:nvPr/>
+        </p:nvSpPr>
+        <p:spPr>
+          <a:xfrm>
+            <a:off x="1463040" y="1508760"/>
+            <a:ext cx="3383280" cy="658368"/>
+          </a:xfrm>
+          <a:prstGeom prst="rect">
+            <a:avLst/>
+          </a:prstGeom>
+          <a:noFill/>
+          <a:ln/>
+        </p:spPr>
+        <p:txBody>
+          <a:bodyPr wrap="square" lIns="0" tIns="0" rIns="0" bIns="0" rtlCol="0" anchor="ctr"/>
+          <a:lstStyle/>
+          <a:p>
+            <a:pPr marL="0" indent="0">
+              <a:buNone/>
+            </a:pPr>
+            <a:r>
+              <a:rPr lang="en-US" sz="1600" b="1" dirty="0">
+                <a:solidFill>
+                  <a:srgbClr val="141413"/>
+                </a:solidFill>
+                <a:latin typeface="Inter" pitchFamily="34" charset="0"/>
+                <a:ea typeface="Inter" pitchFamily="34" charset="-122"/>
+                <a:cs typeface="Inter" pitchFamily="34" charset="-120"/>
+              </a:rPr>
+              <a:t>Loaded at session start</a:t>
+            </a:r>
+            <a:endParaRPr lang="en-US" sz="1600" dirty="0"/>
+          </a:p>
+        </p:txBody>
+      </p:sp>
+      <p:sp>
+        <p:nvSpPr>
+          <p:cNvPr id="9" name="Text 5"/>
+          <p:cNvSpPr/>
+          <p:nvPr/>
+        </p:nvSpPr>
+        <p:spPr>
+          <a:xfrm>
+            <a:off x="4846320" y="1508760"/>
+            <a:ext cx="3566160" cy="658368"/>
+          </a:xfrm>
+          <a:prstGeom prst="rect">
+            <a:avLst/>
+          </a:prstGeom>
+          <a:noFill/>
+          <a:ln/>
+        </p:spPr>
+        <p:txBody>
+          <a:bodyPr wrap="square" lIns="0" tIns="0" rIns="0" bIns="0" rtlCol="0" anchor="ctr"/>
+          <a:lstStyle/>
+          <a:p>
+            <a:pPr marL="0" indent="0">
+              <a:buNone/>
+            </a:pPr>
+            <a:r>
+              <a:rPr lang="en-US" sz="1350" dirty="0">
+                <a:solidFill>
+                  <a:srgbClr val="615C52"/>
+                </a:solidFill>
+                <a:latin typeface="Inter" pitchFamily="34" charset="0"/>
+                <a:ea typeface="Inter" pitchFamily="34" charset="-122"/>
+                <a:cs typeface="Inter" pitchFamily="34" charset="-120"/>
+              </a:rPr>
+              <a:t>Becomes part of the system prompt</a:t>
+            </a:r>
+            <a:endParaRPr lang="en-US" sz="1350" dirty="0"/>
+          </a:p>
+        </p:txBody>
+      </p:sp>
+      <p:sp>
+        <p:nvSpPr>
+          <p:cNvPr id="10" name="Shape 6"/>
+          <p:cNvSpPr/>
+          <p:nvPr/>
+        </p:nvSpPr>
+        <p:spPr>
+          <a:xfrm>
+            <a:off x="548640" y="2276856"/>
+            <a:ext cx="8046720" cy="658368"/>
+          </a:xfrm>
+          <a:prstGeom prst="roundRect">
+            <a:avLst>
+              <a:gd name="adj" fmla="val 8333"/>
+            </a:avLst>
+          </a:prstGeom>
+          <a:solidFill>
+            <a:srgbClr val="FFFFFF"/>
+          </a:solidFill>
+          <a:ln w="12700">
+            <a:solidFill>
+              <a:srgbClr val="E4E1D6"/>
+            </a:solidFill>
+            <a:prstDash val="solid"/>
+          </a:ln>
+        </p:spPr>
+        <p:txBody>
+          <a:bodyPr/>
+          <a:lstStyle/>
+          <a:p>
+            <a:endParaRPr lang="en-US"/>
+          </a:p>
+        </p:txBody>
+      </p:sp>
+      <p:sp>
+        <p:nvSpPr>
+          <p:cNvPr id="11" name="Shape 7"/>
+          <p:cNvSpPr/>
+          <p:nvPr/>
+        </p:nvSpPr>
+        <p:spPr>
+          <a:xfrm>
+            <a:off x="749808" y="2395728"/>
+            <a:ext cx="420624" cy="420624"/>
+          </a:xfrm>
+          <a:prstGeom prst="ellipse">
+            <a:avLst/>
+          </a:prstGeom>
+          <a:solidFill>
+            <a:srgbClr val="D97757"/>
+          </a:solidFill>
+          <a:ln/>
+        </p:spPr>
+        <p:txBody>
+          <a:bodyPr/>
+          <a:lstStyle/>
+          <a:p>
+            <a:endParaRPr lang="en-US"/>
+          </a:p>
+        </p:txBody>
+      </p:sp>
+      <p:pic>
+        <p:nvPicPr>
+          <p:cNvPr id="12" name="Image 2" descr="preencoded.png"/>
+          <p:cNvPicPr>
+            <a:picLocks noChangeAspect="1"/>
+          </p:cNvPicPr>
+          <p:nvPr/>
+        </p:nvPicPr>
+        <p:blipFill>
+          <a:blip r:embed="rId5"/>
+          <a:stretch>
+            <a:fillRect/>
+          </a:stretch>
+        </p:blipFill>
+        <p:spPr>
+          <a:xfrm>
+            <a:off x="859170" y="2505090"/>
+            <a:ext cx="201900" cy="201900"/>
+          </a:xfrm>
+          <a:prstGeom prst="rect">
+            <a:avLst/>
+          </a:prstGeom>
+        </p:spPr>
+      </p:pic>
+      <p:sp>
+        <p:nvSpPr>
+          <p:cNvPr id="13" name="Text 8"/>
+          <p:cNvSpPr/>
+          <p:nvPr/>
+        </p:nvSpPr>
+        <p:spPr>
+          <a:xfrm>
+            <a:off x="1463040" y="2276856"/>
+            <a:ext cx="3383280" cy="658368"/>
+          </a:xfrm>
+          <a:prstGeom prst="rect">
+            <a:avLst/>
+          </a:prstGeom>
+          <a:noFill/>
+          <a:ln/>
+        </p:spPr>
+        <p:txBody>
+          <a:bodyPr wrap="square" lIns="0" tIns="0" rIns="0" bIns="0" rtlCol="0" anchor="ctr"/>
+          <a:lstStyle/>
+          <a:p>
+            <a:pPr marL="0" indent="0">
+              <a:buNone/>
+            </a:pPr>
+            <a:r>
+              <a:rPr lang="en-US" sz="1600" b="1" dirty="0">
+                <a:solidFill>
+                  <a:srgbClr val="141413"/>
+                </a:solidFill>
+                <a:latin typeface="Inter" pitchFamily="34" charset="0"/>
+                <a:ea typeface="Inter" pitchFamily="34" charset="-122"/>
+                <a:cs typeface="Inter" pitchFamily="34" charset="-120"/>
+              </a:rPr>
+              <a:t>Bootstrap with /init</a:t>
+            </a:r>
+            <a:endParaRPr lang="en-US" sz="1600" dirty="0"/>
+          </a:p>
+        </p:txBody>
+      </p:sp>
+      <p:sp>
+        <p:nvSpPr>
+          <p:cNvPr id="14" name="Text 9"/>
+          <p:cNvSpPr/>
+          <p:nvPr/>
+        </p:nvSpPr>
+        <p:spPr>
+          <a:xfrm>
+            <a:off x="4846320" y="2276856"/>
+            <a:ext cx="3566160" cy="658368"/>
+          </a:xfrm>
+          <a:prstGeom prst="rect">
+            <a:avLst/>
+          </a:prstGeom>
+          <a:noFill/>
+          <a:ln/>
+        </p:spPr>
+        <p:txBody>
+          <a:bodyPr wrap="square" lIns="0" tIns="0" rIns="0" bIns="0" rtlCol="0" anchor="ctr"/>
+          <a:lstStyle/>
+          <a:p>
+            <a:pPr marL="0" indent="0">
+              <a:buNone/>
+            </a:pPr>
+            <a:r>
+              <a:rPr lang="en-US" sz="1350" dirty="0">
+                <a:solidFill>
+                  <a:srgbClr val="615C52"/>
+                </a:solidFill>
+                <a:latin typeface="Inter" pitchFamily="34" charset="0"/>
+                <a:ea typeface="Inter" pitchFamily="34" charset="-122"/>
+                <a:cs typeface="Inter" pitchFamily="34" charset="-120"/>
+              </a:rPr>
+              <a:t>Generates a first draft for the repo</a:t>
+            </a:r>
+            <a:endParaRPr lang="en-US" sz="1350" dirty="0"/>
+          </a:p>
+        </p:txBody>
+      </p:sp>
+      <p:sp>
+        <p:nvSpPr>
+          <p:cNvPr id="15" name="Shape 10"/>
+          <p:cNvSpPr/>
+          <p:nvPr/>
+        </p:nvSpPr>
+        <p:spPr>
+          <a:xfrm>
+            <a:off x="548640" y="3044952"/>
+            <a:ext cx="8046720" cy="658368"/>
+          </a:xfrm>
+          <a:prstGeom prst="roundRect">
+            <a:avLst>
+              <a:gd name="adj" fmla="val 8333"/>
+            </a:avLst>
+          </a:prstGeom>
+          <a:solidFill>
+            <a:srgbClr val="FFFFFF"/>
+          </a:solidFill>
+          <a:ln w="12700">
+            <a:solidFill>
+              <a:srgbClr val="E4E1D6"/>
+            </a:solidFill>
+            <a:prstDash val="solid"/>
+          </a:ln>
+        </p:spPr>
+        <p:txBody>
+          <a:bodyPr/>
+          <a:lstStyle/>
+          <a:p>
+            <a:endParaRPr lang="en-US"/>
+          </a:p>
+        </p:txBody>
+      </p:sp>
+      <p:sp>
+        <p:nvSpPr>
+          <p:cNvPr id="16" name="Shape 11"/>
+          <p:cNvSpPr/>
+          <p:nvPr/>
+        </p:nvSpPr>
+        <p:spPr>
+          <a:xfrm>
+            <a:off x="749808" y="3163824"/>
+            <a:ext cx="420624" cy="420624"/>
+          </a:xfrm>
+          <a:prstGeom prst="ellipse">
+            <a:avLst/>
+          </a:prstGeom>
+          <a:solidFill>
+            <a:srgbClr val="D97757"/>
+          </a:solidFill>
+          <a:ln/>
+        </p:spPr>
+        <p:txBody>
+          <a:bodyPr/>
+          <a:lstStyle/>
+          <a:p>
+            <a:endParaRPr lang="en-US"/>
+          </a:p>
+        </p:txBody>
+      </p:sp>
+      <p:pic>
+        <p:nvPicPr>
+          <p:cNvPr id="17" name="Image 3" descr="preencoded.png"/>
+          <p:cNvPicPr>
+            <a:picLocks noChangeAspect="1"/>
+          </p:cNvPicPr>
+          <p:nvPr/>
+        </p:nvPicPr>
+        <p:blipFill>
+          <a:blip r:embed="rId6"/>
+          <a:stretch>
+            <a:fillRect/>
+          </a:stretch>
+        </p:blipFill>
+        <p:spPr>
+          <a:xfrm>
+            <a:off x="859170" y="3273186"/>
+            <a:ext cx="201900" cy="201900"/>
+          </a:xfrm>
+          <a:prstGeom prst="rect">
+            <a:avLst/>
+          </a:prstGeom>
+        </p:spPr>
+      </p:pic>
+      <p:sp>
+        <p:nvSpPr>
+          <p:cNvPr id="18" name="Text 12"/>
+          <p:cNvSpPr/>
+          <p:nvPr/>
+        </p:nvSpPr>
+        <p:spPr>
+          <a:xfrm>
+            <a:off x="1463040" y="3044952"/>
+            <a:ext cx="3383280" cy="658368"/>
+          </a:xfrm>
+          <a:prstGeom prst="rect">
+            <a:avLst/>
+          </a:prstGeom>
+          <a:noFill/>
+          <a:ln/>
+        </p:spPr>
+        <p:txBody>
+          <a:bodyPr wrap="square" lIns="0" tIns="0" rIns="0" bIns="0" rtlCol="0" anchor="ctr"/>
+          <a:lstStyle/>
+          <a:p>
+            <a:pPr marL="0" indent="0">
+              <a:buNone/>
+            </a:pPr>
+            <a:r>
+              <a:rPr lang="en-US" sz="1600" b="1" dirty="0">
+                <a:solidFill>
+                  <a:srgbClr val="141413"/>
+                </a:solidFill>
+                <a:latin typeface="Inter" pitchFamily="34" charset="0"/>
+                <a:ea typeface="Inter" pitchFamily="34" charset="-122"/>
+                <a:cs typeface="Inter" pitchFamily="34" charset="-120"/>
+              </a:rPr>
+              <a:t>Append with #</a:t>
+            </a:r>
+            <a:endParaRPr lang="en-US" sz="1600" dirty="0"/>
+          </a:p>
+        </p:txBody>
+      </p:sp>
+      <p:sp>
+        <p:nvSpPr>
+          <p:cNvPr id="19" name="Text 13"/>
+          <p:cNvSpPr/>
+          <p:nvPr/>
+        </p:nvSpPr>
+        <p:spPr>
+          <a:xfrm>
+            <a:off x="4846320" y="3044952"/>
+            <a:ext cx="3566160" cy="658368"/>
+          </a:xfrm>
+          <a:prstGeom prst="rect">
+            <a:avLst/>
+          </a:prstGeom>
+          <a:noFill/>
+          <a:ln/>
+        </p:spPr>
+        <p:txBody>
+          <a:bodyPr wrap="square" lIns="0" tIns="0" rIns="0" bIns="0" rtlCol="0" anchor="ctr"/>
+          <a:lstStyle/>
+          <a:p>
+            <a:pPr marL="0" indent="0">
+              <a:buNone/>
+            </a:pPr>
+            <a:r>
+              <a:rPr lang="en-US" sz="1350" dirty="0">
+                <a:solidFill>
+                  <a:srgbClr val="615C52"/>
+                </a:solidFill>
+                <a:latin typeface="Inter" pitchFamily="34" charset="0"/>
+                <a:ea typeface="Inter" pitchFamily="34" charset="-122"/>
+                <a:cs typeface="Inter" pitchFamily="34" charset="-120"/>
+              </a:rPr>
+              <a:t>Quickly add a fact mid-session</a:t>
+            </a:r>
+            <a:endParaRPr lang="en-US" sz="1350" dirty="0"/>
+          </a:p>
+        </p:txBody>
+      </p:sp>
+      <p:sp>
+        <p:nvSpPr>
+          <p:cNvPr id="20" name="Text 14"/>
+          <p:cNvSpPr/>
+          <p:nvPr/>
+        </p:nvSpPr>
+        <p:spPr>
+          <a:xfrm>
+            <a:off x="548640" y="3858768"/>
+            <a:ext cx="8046720" cy="274320"/>
+          </a:xfrm>
+          <a:prstGeom prst="rect">
+            <a:avLst/>
+          </a:prstGeom>
+          <a:noFill/>
+          <a:ln/>
+        </p:spPr>
+        <p:txBody>
+          <a:bodyPr wrap="square" lIns="0" tIns="0" rIns="0" bIns="0" rtlCol="0" anchor="ctr"/>
+          <a:lstStyle/>
+          <a:p>
+            <a:pPr marL="0" indent="0" algn="ctr">
+              <a:buNone/>
+            </a:pPr>
+            <a:r>
+              <a:rPr lang="en-US" sz="1300" i="1" dirty="0">
+                <a:solidFill>
+                  <a:srgbClr val="D97757"/>
+                </a:solidFill>
+                <a:latin typeface="Inter" pitchFamily="34" charset="0"/>
+                <a:ea typeface="Inter" pitchFamily="34" charset="-122"/>
+                <a:cs typeface="Inter" pitchFamily="34" charset="-120"/>
+              </a:rPr>
+              <a:t>Deep treatment in Section 2</a:t>
+            </a:r>
+            <a:endParaRPr lang="en-US" sz="1300" dirty="0"/>
+          </a:p>
+        </p:txBody>
+      </p:sp>
+      <p:sp>
+        <p:nvSpPr>
+          <p:cNvPr id="21" name="Text 15"/>
+          <p:cNvSpPr/>
+          <p:nvPr/>
+        </p:nvSpPr>
+        <p:spPr>
+          <a:xfrm>
+            <a:off x="548640" y="4818888"/>
+            <a:ext cx="3657600" cy="274320"/>
+          </a:xfrm>
+          <a:prstGeom prst="rect">
+            <a:avLst/>
+          </a:prstGeom>
+          <a:noFill/>
+          <a:ln/>
+        </p:spPr>
+        <p:txBody>
+          <a:bodyPr wrap="square" rtlCol="0" anchor="ctr"/>
+          <a:lstStyle/>
+          <a:p>
+            <a:pPr marL="0" indent="0">
+              <a:buNone/>
+            </a:pPr>
+            <a:r>
+              <a:rPr lang="en-US" sz="900" dirty="0">
+                <a:solidFill>
+                  <a:srgbClr val="615C52"/>
+                </a:solidFill>
+                <a:latin typeface="Inter" pitchFamily="34" charset="0"/>
+                <a:ea typeface="Inter" pitchFamily="34" charset="-122"/>
+                <a:cs typeface="Inter" pitchFamily="34" charset="-120"/>
+              </a:rPr>
+              <a:t>dotnetclaude.com</a:t>
+            </a:r>
+            <a:endParaRPr lang="en-US" sz="900" dirty="0"/>
+          </a:p>
+        </p:txBody>
+      </p:sp>
+      <p:sp>
+        <p:nvSpPr>
+          <p:cNvPr id="22" name="Text 16"/>
+          <p:cNvSpPr/>
+          <p:nvPr/>
+        </p:nvSpPr>
+        <p:spPr>
+          <a:xfrm>
+            <a:off x="4937760" y="4818888"/>
+            <a:ext cx="3657600" cy="274320"/>
+          </a:xfrm>
+          <a:prstGeom prst="rect">
+            <a:avLst/>
+          </a:prstGeom>
+          <a:noFill/>
+          <a:ln/>
+        </p:spPr>
+        <p:txBody>
+          <a:bodyPr wrap="square" rtlCol="0" anchor="ctr"/>
+          <a:lstStyle/>
+          <a:p>
+            <a:pPr marL="0" indent="0" algn="r">
+              <a:buNone/>
+            </a:pPr>
+            <a:r>
+              <a:rPr lang="en-US" sz="900" dirty="0">
+                <a:solidFill>
+                  <a:srgbClr val="615C52"/>
+                </a:solidFill>
+                <a:latin typeface="Inter" pitchFamily="34" charset="0"/>
+                <a:ea typeface="Inter" pitchFamily="34" charset="-122"/>
+                <a:cs typeface="Inter" pitchFamily="34" charset="-120"/>
+              </a:rPr>
+              <a:t>Section 1  ·  10/14</a:t>
+            </a:r>
+            <a:endParaRPr lang="en-US" sz="900" dirty="0"/>
+          </a:p>
+        </p:txBody>
+      </p:sp>
+    </p:spTree>
+  </p:cSld>
+  <p:clrMapOvr>
+    <a:masterClrMapping/>
+  </p:clrMapOvr>
+</p:sld>
+</file>
+
+<file path=ppt/slides/slide11.xml><?xml version="1.0" encoding="utf-8"?>
 <p:sld xmlns:a="http://schemas.openxmlformats.org/drawingml/2006/main" xmlns:r="http://schemas.openxmlformats.org/officeDocument/2006/relationships" xmlns:p="http://schemas.openxmlformats.org/presentationml/2006/main">
   <p:cSld name="Slide 10">
     <p:bg>
@@ -829,7 +2830,7 @@
           <p:nvPr/>
         </p:nvPicPr>
         <p:blipFill>
-          <a:blip r:embed="rId2"/>
+          <a:blip r:embed="rId3"/>
           <a:stretch>
             <a:fillRect/>
           </a:stretch>
@@ -921,7 +2922,7 @@
           <p:nvPr/>
         </p:nvPicPr>
         <p:blipFill>
-          <a:blip r:embed="rId3"/>
+          <a:blip r:embed="rId4"/>
           <a:stretch>
             <a:fillRect/>
           </a:stretch>
@@ -1091,7 +3092,7 @@
           <p:nvPr/>
         </p:nvPicPr>
         <p:blipFill>
-          <a:blip r:embed="rId4"/>
+          <a:blip r:embed="rId5"/>
           <a:stretch>
             <a:fillRect/>
           </a:stretch>
@@ -1261,7 +3262,7 @@
           <p:nvPr/>
         </p:nvPicPr>
         <p:blipFill>
-          <a:blip r:embed="rId5"/>
+          <a:blip r:embed="rId6"/>
           <a:stretch>
             <a:fillRect/>
           </a:stretch>
@@ -1426,7 +3427,7 @@
                 <a:ea typeface="Inter" pitchFamily="34" charset="-122"/>
                 <a:cs typeface="Inter" pitchFamily="34" charset="-120"/>
               </a:rPr>
-              <a:t>Section 1  ·  10/13</a:t>
+              <a:t>Section 1  ·  11/14</a:t>
             </a:r>
             <a:endParaRPr lang="en-US" sz="900" dirty="0"/>
           </a:p>
@@ -1440,7 +3441,7 @@
 </p:sld>
 </file>
 
-<file path=ppt/slides/slide11.xml><?xml version="1.0" encoding="utf-8"?>
+<file path=ppt/slides/slide12.xml><?xml version="1.0" encoding="utf-8"?>
 <p:sld xmlns:a="http://schemas.openxmlformats.org/drawingml/2006/main" xmlns:r="http://schemas.openxmlformats.org/officeDocument/2006/relationships" xmlns:p="http://schemas.openxmlformats.org/presentationml/2006/main">
   <p:cSld name="Slide 11">
     <p:bg>
@@ -1474,7 +3475,7 @@
           <p:nvPr/>
         </p:nvPicPr>
         <p:blipFill>
-          <a:blip r:embed="rId2"/>
+          <a:blip r:embed="rId3"/>
           <a:stretch>
             <a:fillRect/>
           </a:stretch>
@@ -1709,7 +3710,7 @@
           <p:nvPr/>
         </p:nvPicPr>
         <p:blipFill>
-          <a:blip r:embed="rId3"/>
+          <a:blip r:embed="rId4"/>
           <a:stretch>
             <a:fillRect/>
           </a:stretch>
@@ -1799,7 +3800,7 @@
           <p:nvPr/>
         </p:nvPicPr>
         <p:blipFill>
-          <a:blip r:embed="rId3"/>
+          <a:blip r:embed="rId4"/>
           <a:stretch>
             <a:fillRect/>
           </a:stretch>
@@ -1889,7 +3890,7 @@
           <p:nvPr/>
         </p:nvPicPr>
         <p:blipFill>
-          <a:blip r:embed="rId3"/>
+          <a:blip r:embed="rId4"/>
           <a:stretch>
             <a:fillRect/>
           </a:stretch>
@@ -1979,7 +3980,7 @@
           <p:nvPr/>
         </p:nvPicPr>
         <p:blipFill>
-          <a:blip r:embed="rId3"/>
+          <a:blip r:embed="rId4"/>
           <a:stretch>
             <a:fillRect/>
           </a:stretch>
@@ -2105,7 +4106,7 @@
                 <a:ea typeface="Inter" pitchFamily="34" charset="-122"/>
                 <a:cs typeface="Inter" pitchFamily="34" charset="-120"/>
               </a:rPr>
-              <a:t>Section 1  ·  11/13</a:t>
+              <a:t>Section 1  ·  12/14</a:t>
             </a:r>
             <a:endParaRPr lang="en-US" sz="900" dirty="0"/>
           </a:p>
@@ -2119,7 +4120,7 @@
 </p:sld>
 </file>
 
-<file path=ppt/slides/slide12.xml><?xml version="1.0" encoding="utf-8"?>
+<file path=ppt/slides/slide13.xml><?xml version="1.0" encoding="utf-8"?>
 <p:sld xmlns:a="http://schemas.openxmlformats.org/drawingml/2006/main" xmlns:r="http://schemas.openxmlformats.org/officeDocument/2006/relationships" xmlns:p="http://schemas.openxmlformats.org/presentationml/2006/main">
   <p:cSld name="Slide 12">
     <p:bg>
@@ -2231,7 +4232,7 @@
           <p:nvPr/>
         </p:nvPicPr>
         <p:blipFill>
-          <a:blip r:embed="rId2"/>
+          <a:blip r:embed="rId3"/>
           <a:stretch>
             <a:fillRect/>
           </a:stretch>
@@ -2323,7 +4324,7 @@
           <p:nvPr/>
         </p:nvPicPr>
         <p:blipFill>
-          <a:blip r:embed="rId3"/>
+          <a:blip r:embed="rId4"/>
           <a:stretch>
             <a:fillRect/>
           </a:stretch>
@@ -2454,7 +4455,7 @@
           <p:nvPr/>
         </p:nvPicPr>
         <p:blipFill>
-          <a:blip r:embed="rId4"/>
+          <a:blip r:embed="rId5"/>
           <a:stretch>
             <a:fillRect/>
           </a:stretch>
@@ -2585,7 +4586,7 @@
           <p:nvPr/>
         </p:nvPicPr>
         <p:blipFill>
-          <a:blip r:embed="rId5"/>
+          <a:blip r:embed="rId6"/>
           <a:stretch>
             <a:fillRect/>
           </a:stretch>
@@ -2716,7 +4717,7 @@
           <p:nvPr/>
         </p:nvPicPr>
         <p:blipFill>
-          <a:blip r:embed="rId6"/>
+          <a:blip r:embed="rId7"/>
           <a:stretch>
             <a:fillRect/>
           </a:stretch>
@@ -2842,7 +4843,7 @@
                 <a:ea typeface="Inter" pitchFamily="34" charset="-122"/>
                 <a:cs typeface="Inter" pitchFamily="34" charset="-120"/>
               </a:rPr>
-              <a:t>Section 1  ·  12/13</a:t>
+              <a:t>Section 1  ·  13/14</a:t>
             </a:r>
             <a:endParaRPr lang="en-US" sz="900" dirty="0"/>
           </a:p>
@@ -2856,7 +4857,7 @@
 </p:sld>
 </file>
 
-<file path=ppt/slides/slide13.xml><?xml version="1.0" encoding="utf-8"?>
+<file path=ppt/slides/slide14.xml><?xml version="1.0" encoding="utf-8"?>
 <p:sld xmlns:a="http://schemas.openxmlformats.org/drawingml/2006/main" xmlns:r="http://schemas.openxmlformats.org/officeDocument/2006/relationships" xmlns:p="http://schemas.openxmlformats.org/presentationml/2006/main">
   <p:cSld name="Slide 13">
     <p:bg>
@@ -2890,7 +4891,7 @@
           <p:nvPr/>
         </p:nvPicPr>
         <p:blipFill>
-          <a:blip r:embed="rId2"/>
+          <a:blip r:embed="rId3"/>
           <a:stretch>
             <a:fillRect/>
           </a:stretch>
@@ -2950,7 +4951,7 @@
           <p:nvPr/>
         </p:nvPicPr>
         <p:blipFill>
-          <a:blip r:embed="rId3"/>
+          <a:blip r:embed="rId4"/>
           <a:stretch>
             <a:fillRect/>
           </a:stretch>
@@ -3587,7 +5588,7 @@
           <p:nvPr/>
         </p:nvPicPr>
         <p:blipFill>
-          <a:blip r:embed="rId4"/>
+          <a:blip r:embed="rId5"/>
           <a:stretch>
             <a:fillRect/>
           </a:stretch>
@@ -3650,7 +5651,7 @@
           <p:nvPr/>
         </p:nvPicPr>
         <p:blipFill>
-          <a:blip r:embed="rId4"/>
+          <a:blip r:embed="rId5"/>
           <a:stretch>
             <a:fillRect/>
           </a:stretch>
@@ -3713,7 +5714,7 @@
           <p:nvPr/>
         </p:nvPicPr>
         <p:blipFill>
-          <a:blip r:embed="rId4"/>
+          <a:blip r:embed="rId5"/>
           <a:stretch>
             <a:fillRect/>
           </a:stretch>
@@ -3776,7 +5777,7 @@
           <p:nvPr/>
         </p:nvPicPr>
         <p:blipFill>
-          <a:blip r:embed="rId4"/>
+          <a:blip r:embed="rId5"/>
           <a:stretch>
             <a:fillRect/>
           </a:stretch>
@@ -3902,7 +5903,7 @@
                 <a:ea typeface="Inter" pitchFamily="34" charset="-122"/>
                 <a:cs typeface="Inter" pitchFamily="34" charset="-120"/>
               </a:rPr>
-              <a:t>Section 1  ·  13/13</a:t>
+              <a:t>Section 1  ·  14/14</a:t>
             </a:r>
             <a:endParaRPr lang="en-US" sz="900" dirty="0"/>
           </a:p>
@@ -4028,7 +6029,7 @@
           <p:nvPr/>
         </p:nvPicPr>
         <p:blipFill>
-          <a:blip r:embed="rId2"/>
+          <a:blip r:embed="rId3"/>
           <a:stretch>
             <a:fillRect/>
           </a:stretch>
@@ -4079,7 +6080,7 @@
           <p:nvPr/>
         </p:nvPicPr>
         <p:blipFill>
-          <a:blip r:embed="rId3"/>
+          <a:blip r:embed="rId4"/>
           <a:stretch>
             <a:fillRect/>
           </a:stretch>
@@ -4169,7 +6170,7 @@
           <p:nvPr/>
         </p:nvPicPr>
         <p:blipFill>
-          <a:blip r:embed="rId3"/>
+          <a:blip r:embed="rId4"/>
           <a:stretch>
             <a:fillRect/>
           </a:stretch>
@@ -4259,7 +6260,7 @@
           <p:nvPr/>
         </p:nvPicPr>
         <p:blipFill>
-          <a:blip r:embed="rId3"/>
+          <a:blip r:embed="rId4"/>
           <a:stretch>
             <a:fillRect/>
           </a:stretch>
@@ -4349,7 +6350,7 @@
           <p:nvPr/>
         </p:nvPicPr>
         <p:blipFill>
-          <a:blip r:embed="rId3"/>
+          <a:blip r:embed="rId4"/>
           <a:stretch>
             <a:fillRect/>
           </a:stretch>
@@ -4439,7 +6440,7 @@
           <p:nvPr/>
         </p:nvPicPr>
         <p:blipFill>
-          <a:blip r:embed="rId3"/>
+          <a:blip r:embed="rId4"/>
           <a:stretch>
             <a:fillRect/>
           </a:stretch>
@@ -4529,7 +6530,7 @@
           <p:nvPr/>
         </p:nvPicPr>
         <p:blipFill>
-          <a:blip r:embed="rId3"/>
+          <a:blip r:embed="rId4"/>
           <a:stretch>
             <a:fillRect/>
           </a:stretch>
@@ -4619,7 +6620,7 @@
           <p:nvPr/>
         </p:nvPicPr>
         <p:blipFill>
-          <a:blip r:embed="rId3"/>
+          <a:blip r:embed="rId4"/>
           <a:stretch>
             <a:fillRect/>
           </a:stretch>
@@ -4745,7 +6746,7 @@
                 <a:ea typeface="Inter" pitchFamily="34" charset="-122"/>
                 <a:cs typeface="Inter" pitchFamily="34" charset="-120"/>
               </a:rPr>
-              <a:t>Section 1  ·  2/13</a:t>
+              <a:t>Section 1  ·  2/14</a:t>
             </a:r>
             <a:endParaRPr lang="en-US" sz="900" dirty="0"/>
           </a:p>
@@ -4871,7 +6872,7 @@
           <p:nvPr/>
         </p:nvPicPr>
         <p:blipFill>
-          <a:blip r:embed="rId2"/>
+          <a:blip r:embed="rId3"/>
           <a:stretch>
             <a:fillRect/>
           </a:stretch>
@@ -5322,7 +7323,7 @@
                 <a:ea typeface="Inter" pitchFamily="34" charset="-122"/>
                 <a:cs typeface="Inter" pitchFamily="34" charset="-120"/>
               </a:rPr>
-              <a:t>Section 1  ·  3/13</a:t>
+              <a:t>Section 1  ·  3/14</a:t>
             </a:r>
             <a:endParaRPr lang="en-US" sz="900" dirty="0"/>
           </a:p>
@@ -5448,7 +7449,7 @@
           <p:nvPr/>
         </p:nvPicPr>
         <p:blipFill>
-          <a:blip r:embed="rId2"/>
+          <a:blip r:embed="rId3"/>
           <a:stretch>
             <a:fillRect/>
           </a:stretch>
@@ -5533,7 +7534,7 @@
           <p:nvPr/>
         </p:nvPicPr>
         <p:blipFill>
-          <a:blip r:embed="rId3"/>
+          <a:blip r:embed="rId4"/>
           <a:stretch>
             <a:fillRect/>
           </a:stretch>
@@ -5696,7 +7697,7 @@
           <p:nvPr/>
         </p:nvPicPr>
         <p:blipFill>
-          <a:blip r:embed="rId4"/>
+          <a:blip r:embed="rId5"/>
           <a:stretch>
             <a:fillRect/>
           </a:stretch>
@@ -5859,7 +7860,7 @@
           <p:nvPr/>
         </p:nvPicPr>
         <p:blipFill>
-          <a:blip r:embed="rId5"/>
+          <a:blip r:embed="rId6"/>
           <a:stretch>
             <a:fillRect/>
           </a:stretch>
@@ -6022,7 +8023,7 @@
           <p:nvPr/>
         </p:nvPicPr>
         <p:blipFill>
-          <a:blip r:embed="rId6"/>
+          <a:blip r:embed="rId7"/>
           <a:stretch>
             <a:fillRect/>
           </a:stretch>
@@ -6180,7 +8181,7 @@
           <p:nvPr/>
         </p:nvPicPr>
         <p:blipFill>
-          <a:blip r:embed="rId7"/>
+          <a:blip r:embed="rId8"/>
           <a:stretch>
             <a:fillRect/>
           </a:stretch>
@@ -6317,7 +8318,7 @@
                 <a:ea typeface="Inter" pitchFamily="34" charset="-122"/>
                 <a:cs typeface="Inter" pitchFamily="34" charset="-120"/>
               </a:rPr>
-              <a:t>Section 1  ·  4/13</a:t>
+              <a:t>Section 1  ·  4/14</a:t>
             </a:r>
             <a:endParaRPr lang="en-US" sz="900" dirty="0"/>
           </a:p>
@@ -6443,7 +8444,7 @@
           <p:nvPr/>
         </p:nvPicPr>
         <p:blipFill>
-          <a:blip r:embed="rId2"/>
+          <a:blip r:embed="rId3"/>
           <a:stretch>
             <a:fillRect/>
           </a:stretch>
@@ -7050,7 +9051,7 @@
                 <a:ea typeface="Inter" pitchFamily="34" charset="-122"/>
                 <a:cs typeface="Inter" pitchFamily="34" charset="-120"/>
               </a:rPr>
-              <a:t>Section 1  ·  5/13</a:t>
+              <a:t>Section 1  ·  5/14</a:t>
             </a:r>
             <a:endParaRPr lang="en-US" sz="900" dirty="0"/>
           </a:p>
@@ -7176,7 +9177,7 @@
           <p:nvPr/>
         </p:nvPicPr>
         <p:blipFill>
-          <a:blip r:embed="rId2"/>
+          <a:blip r:embed="rId3"/>
           <a:stretch>
             <a:fillRect/>
           </a:stretch>
@@ -7268,7 +9269,7 @@
           <p:nvPr/>
         </p:nvPicPr>
         <p:blipFill>
-          <a:blip r:embed="rId3"/>
+          <a:blip r:embed="rId4"/>
           <a:stretch>
             <a:fillRect/>
           </a:stretch>
@@ -7477,7 +9478,7 @@
           <p:nvPr/>
         </p:nvPicPr>
         <p:blipFill>
-          <a:blip r:embed="rId4"/>
+          <a:blip r:embed="rId5"/>
           <a:stretch>
             <a:fillRect/>
           </a:stretch>
@@ -7686,7 +9687,7 @@
           <p:nvPr/>
         </p:nvPicPr>
         <p:blipFill>
-          <a:blip r:embed="rId5"/>
+          <a:blip r:embed="rId6"/>
           <a:stretch>
             <a:fillRect/>
           </a:stretch>
@@ -7890,7 +9891,7 @@
                 <a:ea typeface="Inter" pitchFamily="34" charset="-122"/>
                 <a:cs typeface="Inter" pitchFamily="34" charset="-120"/>
               </a:rPr>
-              <a:t>Section 1  ·  6/13</a:t>
+              <a:t>Section 1  ·  6/14</a:t>
             </a:r>
             <a:endParaRPr lang="en-US" sz="900" dirty="0"/>
           </a:p>
@@ -8016,7 +10017,7 @@
           <p:nvPr/>
         </p:nvPicPr>
         <p:blipFill>
-          <a:blip r:embed="rId2"/>
+          <a:blip r:embed="rId3"/>
           <a:stretch>
             <a:fillRect/>
           </a:stretch>
@@ -8478,7 +10479,7 @@
                 <a:ea typeface="Inter" pitchFamily="34" charset="-122"/>
                 <a:cs typeface="Inter" pitchFamily="34" charset="-120"/>
               </a:rPr>
-              <a:t>Section 1  ·  7/13</a:t>
+              <a:t>Section 1  ·  7/14</a:t>
             </a:r>
             <a:endParaRPr lang="en-US" sz="900" dirty="0"/>
           </a:p>
@@ -8604,7 +10605,7 @@
           <p:nvPr/>
         </p:nvPicPr>
         <p:blipFill>
-          <a:blip r:embed="rId2"/>
+          <a:blip r:embed="rId3"/>
           <a:stretch>
             <a:fillRect/>
           </a:stretch>
@@ -9229,7 +11230,7 @@
                 <a:ea typeface="Inter" pitchFamily="34" charset="-122"/>
                 <a:cs typeface="Inter" pitchFamily="34" charset="-120"/>
               </a:rPr>
-              <a:t>Section 1  ·  8/13</a:t>
+              <a:t>Section 1  ·  8/14</a:t>
             </a:r>
             <a:endParaRPr lang="en-US" sz="900" dirty="0"/>
           </a:p>
@@ -9245,15 +11246,7 @@
 
 <file path=ppt/slides/slide9.xml><?xml version="1.0" encoding="utf-8"?>
 <p:sld xmlns:a="http://schemas.openxmlformats.org/drawingml/2006/main" xmlns:r="http://schemas.openxmlformats.org/officeDocument/2006/relationships" xmlns:p="http://schemas.openxmlformats.org/presentationml/2006/main">
-  <p:cSld name="Slide 9">
-    <p:bg>
-      <p:bgPr>
-        <a:solidFill>
-          <a:srgbClr val="F0EEE6"/>
-        </a:solidFill>
-        <a:effectLst/>
-      </p:bgPr>
-    </p:bg>
+  <p:cSld>
     <p:spTree>
       <p:nvGrpSpPr>
         <p:cNvPr id="1" name=""/>
@@ -9301,7 +11294,7 @@
                 <a:ea typeface="Inter" pitchFamily="34" charset="-122"/>
                 <a:cs typeface="Inter" pitchFamily="34" charset="-120"/>
               </a:rPr>
-              <a:t>CLAUDE.MD BASICS</a:t>
+              <a:t>THE DAILY DRIVER SET</a:t>
             </a:r>
             <a:endParaRPr lang="en-US" sz="1100" dirty="0"/>
           </a:p>
@@ -9340,15 +11333,487 @@
                 <a:ea typeface="Georgia" pitchFamily="34" charset="-122"/>
                 <a:cs typeface="Georgia" pitchFamily="34" charset="-120"/>
               </a:rPr>
-              <a:t>Your project briefing (teaser)</a:t>
+              <a:t>Commands you'll use all day</a:t>
             </a:r>
             <a:endParaRPr lang="en-US" sz="2700" dirty="0"/>
+          </a:p>
+        </p:txBody>
+      </p:sp>
+      <p:sp>
+        <p:nvSpPr>
+          <p:cNvPr id="5" name="Shape 2"/>
+          <p:cNvSpPr/>
+          <p:nvPr/>
+        </p:nvSpPr>
+        <p:spPr>
+          <a:xfrm>
+            <a:off x="548640" y="1371600"/>
+            <a:ext cx="8046720" cy="2926080"/>
+          </a:xfrm>
+          <a:prstGeom prst="roundRect">
+            <a:avLst>
+              <a:gd name="adj" fmla="val 2963"/>
+            </a:avLst>
+          </a:prstGeom>
+          <a:solidFill>
+            <a:srgbClr val="1F1E1D"/>
+          </a:solidFill>
+          <a:ln/>
+          <a:effectLst>
+            <a:outerShdw blurRad="88900" dist="38100" dir="5400000" algn="bl" rotWithShape="0">
+              <a:srgbClr val="000000">
+                <a:alpha val="10000"/>
+              </a:srgbClr>
+            </a:outerShdw>
+          </a:effectLst>
+        </p:spPr>
+        <p:txBody>
+          <a:bodyPr/>
+          <a:lstStyle/>
+          <a:p>
+            <a:endParaRPr lang="en-US"/>
+          </a:p>
+        </p:txBody>
+      </p:sp>
+      <p:sp>
+        <p:nvSpPr>
+          <p:cNvPr id="6" name="Text 3"/>
+          <p:cNvSpPr/>
+          <p:nvPr/>
+        </p:nvSpPr>
+        <p:spPr>
+          <a:xfrm>
+            <a:off x="841248" y="1691640"/>
+            <a:ext cx="7498079" cy="2468880"/>
+          </a:xfrm>
+          <a:prstGeom prst="rect">
+            <a:avLst/>
+          </a:prstGeom>
+          <a:noFill/>
+          <a:ln/>
+        </p:spPr>
+        <p:txBody>
+          <a:bodyPr wrap="square" lIns="0" tIns="0" rIns="0" bIns="0" rtlCol="0" anchor="t"/>
+          <a:lstStyle/>
+          <a:p>
+            <a:pPr marL="0" indent="0">
+              <a:lnSpc>
+                <a:spcPct val="150000"/>
+              </a:lnSpc>
+              <a:buNone/>
+            </a:pPr>
+            <a:r>
+              <a:rPr lang="en-US" sz="1300" b="1" dirty="0">
+                <a:solidFill>
+                  <a:srgbClr val="D97757"/>
+                </a:solidFill>
+                <a:latin typeface="Courier New" pitchFamily="34" charset="0"/>
+                <a:ea typeface="Courier New" pitchFamily="34" charset="-122"/>
+                <a:cs typeface="Courier New" pitchFamily="34" charset="-120"/>
+              </a:rPr>
+              <a:t>&gt; </a:t>
+            </a:r>
+            <a:r>
+              <a:rPr lang="en-US" sz="1300" dirty="0">
+                <a:solidFill>
+                  <a:srgbClr val="E9E5DD"/>
+                </a:solidFill>
+                <a:latin typeface="Courier New" pitchFamily="34" charset="0"/>
+                <a:ea typeface="Courier New" pitchFamily="34" charset="-122"/>
+                <a:cs typeface="Courier New" pitchFamily="34" charset="-120"/>
+              </a:rPr>
+              <a:t>/init          </a:t>
+            </a:r>
+            <a:r>
+              <a:rPr lang="en-US" sz="1300" dirty="0">
+                <a:solidFill>
+                  <a:srgbClr val="9A958B"/>
+                </a:solidFill>
+                <a:latin typeface="Courier New" pitchFamily="34" charset="0"/>
+                <a:ea typeface="Courier New" pitchFamily="34" charset="-122"/>
+                <a:cs typeface="Courier New" pitchFamily="34" charset="-120"/>
+              </a:rPr>
+              <a:t># scaffold CLAUDE.md            (Lab 1)</a:t>
+            </a:r>
+            <a:endParaRPr lang="en-US" sz="1300" dirty="0"/>
+          </a:p>
+          <a:p>
+            <a:pPr marL="0" indent="0">
+              <a:lnSpc>
+                <a:spcPct val="150000"/>
+              </a:lnSpc>
+              <a:buNone/>
+            </a:pPr>
+            <a:r>
+              <a:rPr lang="en-US" sz="1300" b="1" dirty="0">
+                <a:solidFill>
+                  <a:srgbClr val="D97757"/>
+                </a:solidFill>
+                <a:latin typeface="Courier New" pitchFamily="34" charset="0"/>
+                <a:ea typeface="Courier New" pitchFamily="34" charset="-122"/>
+                <a:cs typeface="Courier New" pitchFamily="34" charset="-120"/>
+              </a:rPr>
+              <a:t># </a:t>
+            </a:r>
+            <a:r>
+              <a:rPr lang="en-US" sz="1300" dirty="0">
+                <a:solidFill>
+                  <a:srgbClr val="E9E5DD"/>
+                </a:solidFill>
+                <a:latin typeface="Courier New" pitchFamily="34" charset="0"/>
+                <a:ea typeface="Courier New" pitchFamily="34" charset="-122"/>
+                <a:cs typeface="Courier New" pitchFamily="34" charset="-120"/>
+              </a:rPr>
+              <a:t>&lt;fact&gt;         </a:t>
+            </a:r>
+            <a:r>
+              <a:rPr lang="en-US" sz="1300" dirty="0">
+                <a:solidFill>
+                  <a:srgbClr val="9A958B"/>
+                </a:solidFill>
+                <a:latin typeface="Courier New" pitchFamily="34" charset="0"/>
+                <a:ea typeface="Courier New" pitchFamily="34" charset="-122"/>
+                <a:cs typeface="Courier New" pitchFamily="34" charset="-120"/>
+              </a:rPr>
+              <a:t># append a fact to CLAUDE.md    (Lab 1)</a:t>
+            </a:r>
+            <a:endParaRPr lang="en-US" sz="1300" dirty="0"/>
+          </a:p>
+          <a:p>
+            <a:pPr marL="0" indent="0">
+              <a:lnSpc>
+                <a:spcPct val="150000"/>
+              </a:lnSpc>
+              <a:buNone/>
+            </a:pPr>
+            <a:r>
+              <a:rPr lang="en-US" sz="1300" b="1" dirty="0">
+                <a:solidFill>
+                  <a:srgbClr val="D97757"/>
+                </a:solidFill>
+                <a:latin typeface="Courier New" pitchFamily="34" charset="0"/>
+                <a:ea typeface="Courier New" pitchFamily="34" charset="-122"/>
+                <a:cs typeface="Courier New" pitchFamily="34" charset="-120"/>
+              </a:rPr>
+              <a:t>&gt; </a:t>
+            </a:r>
+            <a:r>
+              <a:rPr lang="en-US" sz="1300" dirty="0">
+                <a:solidFill>
+                  <a:srgbClr val="E9E5DD"/>
+                </a:solidFill>
+                <a:latin typeface="Courier New" pitchFamily="34" charset="0"/>
+                <a:ea typeface="Courier New" pitchFamily="34" charset="-122"/>
+                <a:cs typeface="Courier New" pitchFamily="34" charset="-120"/>
+              </a:rPr>
+              <a:t>/memory        </a:t>
+            </a:r>
+            <a:r>
+              <a:rPr lang="en-US" sz="1300" dirty="0">
+                <a:solidFill>
+                  <a:srgbClr val="9A958B"/>
+                </a:solidFill>
+                <a:latin typeface="Courier New" pitchFamily="34" charset="0"/>
+                <a:ea typeface="Courier New" pitchFamily="34" charset="-122"/>
+                <a:cs typeface="Courier New" pitchFamily="34" charset="-120"/>
+              </a:rPr>
+              <a:t># what config is loaded         (Labs 2-4)</a:t>
+            </a:r>
+            <a:endParaRPr lang="en-US" sz="1300" dirty="0"/>
+          </a:p>
+          <a:p>
+            <a:pPr marL="0" indent="0">
+              <a:lnSpc>
+                <a:spcPct val="150000"/>
+              </a:lnSpc>
+              <a:buNone/>
+            </a:pPr>
+            <a:r>
+              <a:rPr lang="en-US" sz="1300" b="1" dirty="0">
+                <a:solidFill>
+                  <a:srgbClr val="D97757"/>
+                </a:solidFill>
+                <a:latin typeface="Courier New" pitchFamily="34" charset="0"/>
+                <a:ea typeface="Courier New" pitchFamily="34" charset="-122"/>
+                <a:cs typeface="Courier New" pitchFamily="34" charset="-120"/>
+              </a:rPr>
+              <a:t>&gt; </a:t>
+            </a:r>
+            <a:r>
+              <a:rPr lang="en-US" sz="1300" dirty="0">
+                <a:solidFill>
+                  <a:srgbClr val="E9E5DD"/>
+                </a:solidFill>
+                <a:latin typeface="Courier New" pitchFamily="34" charset="0"/>
+                <a:ea typeface="Courier New" pitchFamily="34" charset="-122"/>
+                <a:cs typeface="Courier New" pitchFamily="34" charset="-120"/>
+              </a:rPr>
+              <a:t>/clear         </a:t>
+            </a:r>
+            <a:r>
+              <a:rPr lang="en-US" sz="1300" dirty="0">
+                <a:solidFill>
+                  <a:srgbClr val="9A958B"/>
+                </a:solidFill>
+                <a:latin typeface="Courier New" pitchFamily="34" charset="0"/>
+                <a:ea typeface="Courier New" pitchFamily="34" charset="-122"/>
+                <a:cs typeface="Courier New" pitchFamily="34" charset="-120"/>
+              </a:rPr>
+              <a:t># fresh context between tasks   (all day)</a:t>
+            </a:r>
+            <a:endParaRPr lang="en-US" sz="1300" dirty="0"/>
+          </a:p>
+          <a:p>
+            <a:pPr marL="0" indent="0">
+              <a:lnSpc>
+                <a:spcPct val="150000"/>
+              </a:lnSpc>
+              <a:buNone/>
+            </a:pPr>
+            <a:r>
+              <a:rPr lang="en-US" sz="1300" b="1" dirty="0">
+                <a:solidFill>
+                  <a:srgbClr val="D97757"/>
+                </a:solidFill>
+                <a:latin typeface="Courier New" pitchFamily="34" charset="0"/>
+                <a:ea typeface="Courier New" pitchFamily="34" charset="-122"/>
+                <a:cs typeface="Courier New" pitchFamily="34" charset="-120"/>
+              </a:rPr>
+              <a:t>&gt; </a:t>
+            </a:r>
+            <a:r>
+              <a:rPr lang="en-US" sz="1300" dirty="0">
+                <a:solidFill>
+                  <a:srgbClr val="E9E5DD"/>
+                </a:solidFill>
+                <a:latin typeface="Courier New" pitchFamily="34" charset="0"/>
+                <a:ea typeface="Courier New" pitchFamily="34" charset="-122"/>
+                <a:cs typeface="Courier New" pitchFamily="34" charset="-120"/>
+              </a:rPr>
+              <a:t>/compact       </a:t>
+            </a:r>
+            <a:r>
+              <a:rPr lang="en-US" sz="1300" dirty="0">
+                <a:solidFill>
+                  <a:srgbClr val="9A958B"/>
+                </a:solidFill>
+                <a:latin typeface="Courier New" pitchFamily="34" charset="0"/>
+                <a:ea typeface="Courier New" pitchFamily="34" charset="-122"/>
+                <a:cs typeface="Courier New" pitchFamily="34" charset="-120"/>
+              </a:rPr>
+              <a:t># summarize &amp; keep going        (long labs)</a:t>
+            </a:r>
+            <a:endParaRPr lang="en-US" sz="1300" dirty="0"/>
+          </a:p>
+          <a:p>
+            <a:pPr marL="0" indent="0">
+              <a:lnSpc>
+                <a:spcPct val="150000"/>
+              </a:lnSpc>
+              <a:buNone/>
+            </a:pPr>
+            <a:r>
+              <a:rPr lang="en-US" sz="1300" b="1" dirty="0">
+                <a:solidFill>
+                  <a:srgbClr val="D97757"/>
+                </a:solidFill>
+                <a:latin typeface="Courier New" pitchFamily="34" charset="0"/>
+                <a:ea typeface="Courier New" pitchFamily="34" charset="-122"/>
+                <a:cs typeface="Courier New" pitchFamily="34" charset="-120"/>
+              </a:rPr>
+              <a:t>  </a:t>
+            </a:r>
+            <a:r>
+              <a:rPr lang="en-US" sz="1300" dirty="0">
+                <a:solidFill>
+                  <a:srgbClr val="E9E5DD"/>
+                </a:solidFill>
+                <a:latin typeface="Courier New" pitchFamily="34" charset="0"/>
+                <a:ea typeface="Courier New" pitchFamily="34" charset="-122"/>
+                <a:cs typeface="Courier New" pitchFamily="34" charset="-120"/>
+              </a:rPr>
+              <a:t>@path/to/file  </a:t>
+            </a:r>
+            <a:r>
+              <a:rPr lang="en-US" sz="1300" dirty="0">
+                <a:solidFill>
+                  <a:srgbClr val="9A958B"/>
+                </a:solidFill>
+                <a:latin typeface="Courier New" pitchFamily="34" charset="0"/>
+                <a:ea typeface="Courier New" pitchFamily="34" charset="-122"/>
+                <a:cs typeface="Courier New" pitchFamily="34" charset="-120"/>
+              </a:rPr>
+              <a:t># point Claude at a file        (all day)</a:t>
+            </a:r>
+            <a:endParaRPr lang="en-US" sz="1300" dirty="0"/>
+          </a:p>
+          <a:p>
+            <a:pPr marL="0" indent="0">
+              <a:lnSpc>
+                <a:spcPct val="150000"/>
+              </a:lnSpc>
+              <a:buNone/>
+            </a:pPr>
+            <a:r>
+              <a:rPr lang="en-US" sz="1300" b="1" dirty="0">
+                <a:solidFill>
+                  <a:srgbClr val="D97757"/>
+                </a:solidFill>
+                <a:latin typeface="Courier New" pitchFamily="34" charset="0"/>
+                <a:ea typeface="Courier New" pitchFamily="34" charset="-122"/>
+                <a:cs typeface="Courier New" pitchFamily="34" charset="-120"/>
+              </a:rPr>
+              <a:t>  </a:t>
+            </a:r>
+            <a:r>
+              <a:rPr lang="en-US" sz="1300" dirty="0">
+                <a:solidFill>
+                  <a:srgbClr val="E9E5DD"/>
+                </a:solidFill>
+                <a:latin typeface="Courier New" pitchFamily="34" charset="0"/>
+                <a:ea typeface="Courier New" pitchFamily="34" charset="-122"/>
+                <a:cs typeface="Courier New" pitchFamily="34" charset="-120"/>
+              </a:rPr>
+              <a:t>Esc            </a:t>
+            </a:r>
+            <a:r>
+              <a:rPr lang="en-US" sz="1300" dirty="0">
+                <a:solidFill>
+                  <a:srgbClr val="9A958B"/>
+                </a:solidFill>
+                <a:latin typeface="Courier New" pitchFamily="34" charset="0"/>
+                <a:ea typeface="Courier New" pitchFamily="34" charset="-122"/>
+                <a:cs typeface="Courier New" pitchFamily="34" charset="-120"/>
+              </a:rPr>
+              <a:t># interrupt Claude mid-turn</a:t>
+            </a:r>
+            <a:endParaRPr lang="en-US" sz="1300" dirty="0"/>
+          </a:p>
+          <a:p>
+            <a:pPr marL="0" indent="0">
+              <a:lnSpc>
+                <a:spcPct val="150000"/>
+              </a:lnSpc>
+              <a:buNone/>
+            </a:pPr>
+            <a:r>
+              <a:rPr lang="en-US" sz="1300" b="1" dirty="0">
+                <a:solidFill>
+                  <a:srgbClr val="D97757"/>
+                </a:solidFill>
+                <a:latin typeface="Courier New" pitchFamily="34" charset="0"/>
+                <a:ea typeface="Courier New" pitchFamily="34" charset="-122"/>
+                <a:cs typeface="Courier New" pitchFamily="34" charset="-120"/>
+              </a:rPr>
+              <a:t>  </a:t>
+            </a:r>
+            <a:r>
+              <a:rPr lang="en-US" sz="1300" dirty="0">
+                <a:solidFill>
+                  <a:srgbClr val="E9E5DD"/>
+                </a:solidFill>
+                <a:latin typeface="Courier New" pitchFamily="34" charset="0"/>
+                <a:ea typeface="Courier New" pitchFamily="34" charset="-122"/>
+                <a:cs typeface="Courier New" pitchFamily="34" charset="-120"/>
+              </a:rPr>
+              <a:t>Shift+Tab      </a:t>
+            </a:r>
+            <a:r>
+              <a:rPr lang="en-US" sz="1300" dirty="0">
+                <a:solidFill>
+                  <a:srgbClr val="9A958B"/>
+                </a:solidFill>
+                <a:latin typeface="Courier New" pitchFamily="34" charset="0"/>
+                <a:ea typeface="Courier New" pitchFamily="34" charset="-122"/>
+                <a:cs typeface="Courier New" pitchFamily="34" charset="-120"/>
+              </a:rPr>
+              <a:t># cycle modes -&gt; plan mode      (Section 4)</a:t>
+            </a:r>
+            <a:endParaRPr lang="en-US" sz="1300" dirty="0"/>
+          </a:p>
+        </p:txBody>
+      </p:sp>
+      <p:sp>
+        <p:nvSpPr>
+          <p:cNvPr id="15" name="Text 12"/>
+          <p:cNvSpPr/>
+          <p:nvPr/>
+        </p:nvSpPr>
+        <p:spPr>
+          <a:xfrm>
+            <a:off x="548640" y="4818888"/>
+            <a:ext cx="3657600" cy="274320"/>
+          </a:xfrm>
+          <a:prstGeom prst="rect">
+            <a:avLst/>
+          </a:prstGeom>
+          <a:noFill/>
+          <a:ln/>
+        </p:spPr>
+        <p:txBody>
+          <a:bodyPr wrap="square" rtlCol="0" anchor="ctr"/>
+          <a:lstStyle/>
+          <a:p>
+            <a:pPr marL="0" indent="0">
+              <a:buNone/>
+            </a:pPr>
+            <a:r>
+              <a:rPr lang="en-US" sz="900" dirty="0">
+                <a:solidFill>
+                  <a:srgbClr val="615C52"/>
+                </a:solidFill>
+                <a:latin typeface="Inter" pitchFamily="34" charset="0"/>
+                <a:ea typeface="Inter" pitchFamily="34" charset="-122"/>
+                <a:cs typeface="Inter" pitchFamily="34" charset="-120"/>
+              </a:rPr>
+              <a:t>dotnetclaude.com</a:t>
+            </a:r>
+            <a:endParaRPr lang="en-US" sz="900" dirty="0"/>
+          </a:p>
+        </p:txBody>
+      </p:sp>
+      <p:sp>
+        <p:nvSpPr>
+          <p:cNvPr id="16" name="Text 13"/>
+          <p:cNvSpPr/>
+          <p:nvPr/>
+        </p:nvSpPr>
+        <p:spPr>
+          <a:xfrm>
+            <a:off x="4937760" y="4818888"/>
+            <a:ext cx="3657600" cy="274320"/>
+          </a:xfrm>
+          <a:prstGeom prst="rect">
+            <a:avLst/>
+          </a:prstGeom>
+          <a:noFill/>
+          <a:ln/>
+        </p:spPr>
+        <p:txBody>
+          <a:bodyPr wrap="square" rtlCol="0" anchor="ctr"/>
+          <a:lstStyle/>
+          <a:p>
+            <a:pPr marL="0" indent="0" algn="r">
+              <a:buNone/>
+            </a:pPr>
+            <a:r>
+              <a:rPr lang="en-US" sz="900" dirty="0">
+                <a:solidFill>
+                  <a:srgbClr val="615C52"/>
+                </a:solidFill>
+                <a:latin typeface="Inter" pitchFamily="34" charset="0"/>
+                <a:ea typeface="Inter" pitchFamily="34" charset="-122"/>
+                <a:cs typeface="Inter" pitchFamily="34" charset="-120"/>
+              </a:rPr>
+              <a:t>Section 1  ·  9/14</a:t>
+            </a:r>
+            <a:endParaRPr lang="en-US" sz="900" dirty="0"/>
           </a:p>
         </p:txBody>
       </p:sp>
       <p:pic>
         <p:nvPicPr>
-          <p:cNvPr id="4" name="Image 0" descr="preencoded.png"/>
+          <p:cNvPr id="17" name="Picture 16" descr="image.png"/>
           <p:cNvPicPr>
             <a:picLocks noChangeAspect="1"/>
           </p:cNvPicPr>
@@ -9370,612 +11835,6 @@
           </a:prstGeom>
         </p:spPr>
       </p:pic>
-      <p:sp>
-        <p:nvSpPr>
-          <p:cNvPr id="5" name="Shape 2"/>
-          <p:cNvSpPr/>
-          <p:nvPr/>
-        </p:nvSpPr>
-        <p:spPr>
-          <a:xfrm>
-            <a:off x="548640" y="1508760"/>
-            <a:ext cx="8046720" cy="658368"/>
-          </a:xfrm>
-          <a:prstGeom prst="roundRect">
-            <a:avLst>
-              <a:gd name="adj" fmla="val 8333"/>
-            </a:avLst>
-          </a:prstGeom>
-          <a:solidFill>
-            <a:srgbClr val="FFFFFF"/>
-          </a:solidFill>
-          <a:ln w="12700">
-            <a:solidFill>
-              <a:srgbClr val="E4E1D6"/>
-            </a:solidFill>
-            <a:prstDash val="solid"/>
-          </a:ln>
-        </p:spPr>
-        <p:txBody>
-          <a:bodyPr/>
-          <a:lstStyle/>
-          <a:p>
-            <a:endParaRPr lang="en-US"/>
-          </a:p>
-        </p:txBody>
-      </p:sp>
-      <p:sp>
-        <p:nvSpPr>
-          <p:cNvPr id="6" name="Shape 3"/>
-          <p:cNvSpPr/>
-          <p:nvPr/>
-        </p:nvSpPr>
-        <p:spPr>
-          <a:xfrm>
-            <a:off x="749808" y="1627632"/>
-            <a:ext cx="420624" cy="420624"/>
-          </a:xfrm>
-          <a:prstGeom prst="ellipse">
-            <a:avLst/>
-          </a:prstGeom>
-          <a:solidFill>
-            <a:srgbClr val="D97757"/>
-          </a:solidFill>
-          <a:ln/>
-        </p:spPr>
-        <p:txBody>
-          <a:bodyPr/>
-          <a:lstStyle/>
-          <a:p>
-            <a:endParaRPr lang="en-US"/>
-          </a:p>
-        </p:txBody>
-      </p:sp>
-      <p:pic>
-        <p:nvPicPr>
-          <p:cNvPr id="7" name="Image 1" descr="preencoded.png"/>
-          <p:cNvPicPr>
-            <a:picLocks noChangeAspect="1"/>
-          </p:cNvPicPr>
-          <p:nvPr/>
-        </p:nvPicPr>
-        <p:blipFill>
-          <a:blip r:embed="rId3"/>
-          <a:stretch>
-            <a:fillRect/>
-          </a:stretch>
-        </p:blipFill>
-        <p:spPr>
-          <a:xfrm>
-            <a:off x="859170" y="1736994"/>
-            <a:ext cx="201900" cy="201900"/>
-          </a:xfrm>
-          <a:prstGeom prst="rect">
-            <a:avLst/>
-          </a:prstGeom>
-        </p:spPr>
-      </p:pic>
-      <p:sp>
-        <p:nvSpPr>
-          <p:cNvPr id="8" name="Text 4"/>
-          <p:cNvSpPr/>
-          <p:nvPr/>
-        </p:nvSpPr>
-        <p:spPr>
-          <a:xfrm>
-            <a:off x="1463040" y="1508760"/>
-            <a:ext cx="3383280" cy="658368"/>
-          </a:xfrm>
-          <a:prstGeom prst="rect">
-            <a:avLst/>
-          </a:prstGeom>
-          <a:noFill/>
-          <a:ln/>
-        </p:spPr>
-        <p:txBody>
-          <a:bodyPr wrap="square" lIns="0" tIns="0" rIns="0" bIns="0" rtlCol="0" anchor="ctr"/>
-          <a:lstStyle/>
-          <a:p>
-            <a:pPr marL="0" indent="0">
-              <a:buNone/>
-            </a:pPr>
-            <a:r>
-              <a:rPr lang="en-US" sz="1600" b="1" dirty="0">
-                <a:solidFill>
-                  <a:srgbClr val="141413"/>
-                </a:solidFill>
-                <a:latin typeface="Inter" pitchFamily="34" charset="0"/>
-                <a:ea typeface="Inter" pitchFamily="34" charset="-122"/>
-                <a:cs typeface="Inter" pitchFamily="34" charset="-120"/>
-              </a:rPr>
-              <a:t>Loaded at session start</a:t>
-            </a:r>
-            <a:endParaRPr lang="en-US" sz="1600" dirty="0"/>
-          </a:p>
-        </p:txBody>
-      </p:sp>
-      <p:sp>
-        <p:nvSpPr>
-          <p:cNvPr id="9" name="Text 5"/>
-          <p:cNvSpPr/>
-          <p:nvPr/>
-        </p:nvSpPr>
-        <p:spPr>
-          <a:xfrm>
-            <a:off x="4846320" y="1508760"/>
-            <a:ext cx="3566160" cy="658368"/>
-          </a:xfrm>
-          <a:prstGeom prst="rect">
-            <a:avLst/>
-          </a:prstGeom>
-          <a:noFill/>
-          <a:ln/>
-        </p:spPr>
-        <p:txBody>
-          <a:bodyPr wrap="square" lIns="0" tIns="0" rIns="0" bIns="0" rtlCol="0" anchor="ctr"/>
-          <a:lstStyle/>
-          <a:p>
-            <a:pPr marL="0" indent="0">
-              <a:buNone/>
-            </a:pPr>
-            <a:r>
-              <a:rPr lang="en-US" sz="1350" dirty="0">
-                <a:solidFill>
-                  <a:srgbClr val="615C52"/>
-                </a:solidFill>
-                <a:latin typeface="Inter" pitchFamily="34" charset="0"/>
-                <a:ea typeface="Inter" pitchFamily="34" charset="-122"/>
-                <a:cs typeface="Inter" pitchFamily="34" charset="-120"/>
-              </a:rPr>
-              <a:t>Becomes part of the system prompt</a:t>
-            </a:r>
-            <a:endParaRPr lang="en-US" sz="1350" dirty="0"/>
-          </a:p>
-        </p:txBody>
-      </p:sp>
-      <p:sp>
-        <p:nvSpPr>
-          <p:cNvPr id="10" name="Shape 6"/>
-          <p:cNvSpPr/>
-          <p:nvPr/>
-        </p:nvSpPr>
-        <p:spPr>
-          <a:xfrm>
-            <a:off x="548640" y="2276856"/>
-            <a:ext cx="8046720" cy="658368"/>
-          </a:xfrm>
-          <a:prstGeom prst="roundRect">
-            <a:avLst>
-              <a:gd name="adj" fmla="val 8333"/>
-            </a:avLst>
-          </a:prstGeom>
-          <a:solidFill>
-            <a:srgbClr val="FFFFFF"/>
-          </a:solidFill>
-          <a:ln w="12700">
-            <a:solidFill>
-              <a:srgbClr val="E4E1D6"/>
-            </a:solidFill>
-            <a:prstDash val="solid"/>
-          </a:ln>
-        </p:spPr>
-        <p:txBody>
-          <a:bodyPr/>
-          <a:lstStyle/>
-          <a:p>
-            <a:endParaRPr lang="en-US"/>
-          </a:p>
-        </p:txBody>
-      </p:sp>
-      <p:sp>
-        <p:nvSpPr>
-          <p:cNvPr id="11" name="Shape 7"/>
-          <p:cNvSpPr/>
-          <p:nvPr/>
-        </p:nvSpPr>
-        <p:spPr>
-          <a:xfrm>
-            <a:off x="749808" y="2395728"/>
-            <a:ext cx="420624" cy="420624"/>
-          </a:xfrm>
-          <a:prstGeom prst="ellipse">
-            <a:avLst/>
-          </a:prstGeom>
-          <a:solidFill>
-            <a:srgbClr val="D97757"/>
-          </a:solidFill>
-          <a:ln/>
-        </p:spPr>
-        <p:txBody>
-          <a:bodyPr/>
-          <a:lstStyle/>
-          <a:p>
-            <a:endParaRPr lang="en-US"/>
-          </a:p>
-        </p:txBody>
-      </p:sp>
-      <p:pic>
-        <p:nvPicPr>
-          <p:cNvPr id="12" name="Image 2" descr="preencoded.png"/>
-          <p:cNvPicPr>
-            <a:picLocks noChangeAspect="1"/>
-          </p:cNvPicPr>
-          <p:nvPr/>
-        </p:nvPicPr>
-        <p:blipFill>
-          <a:blip r:embed="rId4"/>
-          <a:stretch>
-            <a:fillRect/>
-          </a:stretch>
-        </p:blipFill>
-        <p:spPr>
-          <a:xfrm>
-            <a:off x="859170" y="2505090"/>
-            <a:ext cx="201900" cy="201900"/>
-          </a:xfrm>
-          <a:prstGeom prst="rect">
-            <a:avLst/>
-          </a:prstGeom>
-        </p:spPr>
-      </p:pic>
-      <p:sp>
-        <p:nvSpPr>
-          <p:cNvPr id="13" name="Text 8"/>
-          <p:cNvSpPr/>
-          <p:nvPr/>
-        </p:nvSpPr>
-        <p:spPr>
-          <a:xfrm>
-            <a:off x="1463040" y="2276856"/>
-            <a:ext cx="3383280" cy="658368"/>
-          </a:xfrm>
-          <a:prstGeom prst="rect">
-            <a:avLst/>
-          </a:prstGeom>
-          <a:noFill/>
-          <a:ln/>
-        </p:spPr>
-        <p:txBody>
-          <a:bodyPr wrap="square" lIns="0" tIns="0" rIns="0" bIns="0" rtlCol="0" anchor="ctr"/>
-          <a:lstStyle/>
-          <a:p>
-            <a:pPr marL="0" indent="0">
-              <a:buNone/>
-            </a:pPr>
-            <a:r>
-              <a:rPr lang="en-US" sz="1600" b="1" dirty="0">
-                <a:solidFill>
-                  <a:srgbClr val="141413"/>
-                </a:solidFill>
-                <a:latin typeface="Inter" pitchFamily="34" charset="0"/>
-                <a:ea typeface="Inter" pitchFamily="34" charset="-122"/>
-                <a:cs typeface="Inter" pitchFamily="34" charset="-120"/>
-              </a:rPr>
-              <a:t>Bootstrap with /init</a:t>
-            </a:r>
-            <a:endParaRPr lang="en-US" sz="1600" dirty="0"/>
-          </a:p>
-        </p:txBody>
-      </p:sp>
-      <p:sp>
-        <p:nvSpPr>
-          <p:cNvPr id="14" name="Text 9"/>
-          <p:cNvSpPr/>
-          <p:nvPr/>
-        </p:nvSpPr>
-        <p:spPr>
-          <a:xfrm>
-            <a:off x="4846320" y="2276856"/>
-            <a:ext cx="3566160" cy="658368"/>
-          </a:xfrm>
-          <a:prstGeom prst="rect">
-            <a:avLst/>
-          </a:prstGeom>
-          <a:noFill/>
-          <a:ln/>
-        </p:spPr>
-        <p:txBody>
-          <a:bodyPr wrap="square" lIns="0" tIns="0" rIns="0" bIns="0" rtlCol="0" anchor="ctr"/>
-          <a:lstStyle/>
-          <a:p>
-            <a:pPr marL="0" indent="0">
-              <a:buNone/>
-            </a:pPr>
-            <a:r>
-              <a:rPr lang="en-US" sz="1350" dirty="0">
-                <a:solidFill>
-                  <a:srgbClr val="615C52"/>
-                </a:solidFill>
-                <a:latin typeface="Inter" pitchFamily="34" charset="0"/>
-                <a:ea typeface="Inter" pitchFamily="34" charset="-122"/>
-                <a:cs typeface="Inter" pitchFamily="34" charset="-120"/>
-              </a:rPr>
-              <a:t>Generates a first draft for the repo</a:t>
-            </a:r>
-            <a:endParaRPr lang="en-US" sz="1350" dirty="0"/>
-          </a:p>
-        </p:txBody>
-      </p:sp>
-      <p:sp>
-        <p:nvSpPr>
-          <p:cNvPr id="15" name="Shape 10"/>
-          <p:cNvSpPr/>
-          <p:nvPr/>
-        </p:nvSpPr>
-        <p:spPr>
-          <a:xfrm>
-            <a:off x="548640" y="3044952"/>
-            <a:ext cx="8046720" cy="658368"/>
-          </a:xfrm>
-          <a:prstGeom prst="roundRect">
-            <a:avLst>
-              <a:gd name="adj" fmla="val 8333"/>
-            </a:avLst>
-          </a:prstGeom>
-          <a:solidFill>
-            <a:srgbClr val="FFFFFF"/>
-          </a:solidFill>
-          <a:ln w="12700">
-            <a:solidFill>
-              <a:srgbClr val="E4E1D6"/>
-            </a:solidFill>
-            <a:prstDash val="solid"/>
-          </a:ln>
-        </p:spPr>
-        <p:txBody>
-          <a:bodyPr/>
-          <a:lstStyle/>
-          <a:p>
-            <a:endParaRPr lang="en-US"/>
-          </a:p>
-        </p:txBody>
-      </p:sp>
-      <p:sp>
-        <p:nvSpPr>
-          <p:cNvPr id="16" name="Shape 11"/>
-          <p:cNvSpPr/>
-          <p:nvPr/>
-        </p:nvSpPr>
-        <p:spPr>
-          <a:xfrm>
-            <a:off x="749808" y="3163824"/>
-            <a:ext cx="420624" cy="420624"/>
-          </a:xfrm>
-          <a:prstGeom prst="ellipse">
-            <a:avLst/>
-          </a:prstGeom>
-          <a:solidFill>
-            <a:srgbClr val="D97757"/>
-          </a:solidFill>
-          <a:ln/>
-        </p:spPr>
-        <p:txBody>
-          <a:bodyPr/>
-          <a:lstStyle/>
-          <a:p>
-            <a:endParaRPr lang="en-US"/>
-          </a:p>
-        </p:txBody>
-      </p:sp>
-      <p:pic>
-        <p:nvPicPr>
-          <p:cNvPr id="17" name="Image 3" descr="preencoded.png"/>
-          <p:cNvPicPr>
-            <a:picLocks noChangeAspect="1"/>
-          </p:cNvPicPr>
-          <p:nvPr/>
-        </p:nvPicPr>
-        <p:blipFill>
-          <a:blip r:embed="rId5"/>
-          <a:stretch>
-            <a:fillRect/>
-          </a:stretch>
-        </p:blipFill>
-        <p:spPr>
-          <a:xfrm>
-            <a:off x="859170" y="3273186"/>
-            <a:ext cx="201900" cy="201900"/>
-          </a:xfrm>
-          <a:prstGeom prst="rect">
-            <a:avLst/>
-          </a:prstGeom>
-        </p:spPr>
-      </p:pic>
-      <p:sp>
-        <p:nvSpPr>
-          <p:cNvPr id="18" name="Text 12"/>
-          <p:cNvSpPr/>
-          <p:nvPr/>
-        </p:nvSpPr>
-        <p:spPr>
-          <a:xfrm>
-            <a:off x="1463040" y="3044952"/>
-            <a:ext cx="3383280" cy="658368"/>
-          </a:xfrm>
-          <a:prstGeom prst="rect">
-            <a:avLst/>
-          </a:prstGeom>
-          <a:noFill/>
-          <a:ln/>
-        </p:spPr>
-        <p:txBody>
-          <a:bodyPr wrap="square" lIns="0" tIns="0" rIns="0" bIns="0" rtlCol="0" anchor="ctr"/>
-          <a:lstStyle/>
-          <a:p>
-            <a:pPr marL="0" indent="0">
-              <a:buNone/>
-            </a:pPr>
-            <a:r>
-              <a:rPr lang="en-US" sz="1600" b="1" dirty="0">
-                <a:solidFill>
-                  <a:srgbClr val="141413"/>
-                </a:solidFill>
-                <a:latin typeface="Inter" pitchFamily="34" charset="0"/>
-                <a:ea typeface="Inter" pitchFamily="34" charset="-122"/>
-                <a:cs typeface="Inter" pitchFamily="34" charset="-120"/>
-              </a:rPr>
-              <a:t>Append with #</a:t>
-            </a:r>
-            <a:endParaRPr lang="en-US" sz="1600" dirty="0"/>
-          </a:p>
-        </p:txBody>
-      </p:sp>
-      <p:sp>
-        <p:nvSpPr>
-          <p:cNvPr id="19" name="Text 13"/>
-          <p:cNvSpPr/>
-          <p:nvPr/>
-        </p:nvSpPr>
-        <p:spPr>
-          <a:xfrm>
-            <a:off x="4846320" y="3044952"/>
-            <a:ext cx="3566160" cy="658368"/>
-          </a:xfrm>
-          <a:prstGeom prst="rect">
-            <a:avLst/>
-          </a:prstGeom>
-          <a:noFill/>
-          <a:ln/>
-        </p:spPr>
-        <p:txBody>
-          <a:bodyPr wrap="square" lIns="0" tIns="0" rIns="0" bIns="0" rtlCol="0" anchor="ctr"/>
-          <a:lstStyle/>
-          <a:p>
-            <a:pPr marL="0" indent="0">
-              <a:buNone/>
-            </a:pPr>
-            <a:r>
-              <a:rPr lang="en-US" sz="1350" dirty="0">
-                <a:solidFill>
-                  <a:srgbClr val="615C52"/>
-                </a:solidFill>
-                <a:latin typeface="Inter" pitchFamily="34" charset="0"/>
-                <a:ea typeface="Inter" pitchFamily="34" charset="-122"/>
-                <a:cs typeface="Inter" pitchFamily="34" charset="-120"/>
-              </a:rPr>
-              <a:t>Quickly add a fact mid-session</a:t>
-            </a:r>
-            <a:endParaRPr lang="en-US" sz="1350" dirty="0"/>
-          </a:p>
-        </p:txBody>
-      </p:sp>
-      <p:sp>
-        <p:nvSpPr>
-          <p:cNvPr id="20" name="Text 14"/>
-          <p:cNvSpPr/>
-          <p:nvPr/>
-        </p:nvSpPr>
-        <p:spPr>
-          <a:xfrm>
-            <a:off x="548640" y="3858768"/>
-            <a:ext cx="8046720" cy="274320"/>
-          </a:xfrm>
-          <a:prstGeom prst="rect">
-            <a:avLst/>
-          </a:prstGeom>
-          <a:noFill/>
-          <a:ln/>
-        </p:spPr>
-        <p:txBody>
-          <a:bodyPr wrap="square" lIns="0" tIns="0" rIns="0" bIns="0" rtlCol="0" anchor="ctr"/>
-          <a:lstStyle/>
-          <a:p>
-            <a:pPr marL="0" indent="0" algn="ctr">
-              <a:buNone/>
-            </a:pPr>
-            <a:r>
-              <a:rPr lang="en-US" sz="1300" i="1" dirty="0">
-                <a:solidFill>
-                  <a:srgbClr val="D97757"/>
-                </a:solidFill>
-                <a:latin typeface="Inter" pitchFamily="34" charset="0"/>
-                <a:ea typeface="Inter" pitchFamily="34" charset="-122"/>
-                <a:cs typeface="Inter" pitchFamily="34" charset="-120"/>
-              </a:rPr>
-              <a:t>Deep treatment in Section 2</a:t>
-            </a:r>
-            <a:endParaRPr lang="en-US" sz="1300" dirty="0"/>
-          </a:p>
-        </p:txBody>
-      </p:sp>
-      <p:sp>
-        <p:nvSpPr>
-          <p:cNvPr id="21" name="Text 15"/>
-          <p:cNvSpPr/>
-          <p:nvPr/>
-        </p:nvSpPr>
-        <p:spPr>
-          <a:xfrm>
-            <a:off x="548640" y="4818888"/>
-            <a:ext cx="3657600" cy="274320"/>
-          </a:xfrm>
-          <a:prstGeom prst="rect">
-            <a:avLst/>
-          </a:prstGeom>
-          <a:noFill/>
-          <a:ln/>
-        </p:spPr>
-        <p:txBody>
-          <a:bodyPr wrap="square" rtlCol="0" anchor="ctr"/>
-          <a:lstStyle/>
-          <a:p>
-            <a:pPr marL="0" indent="0">
-              <a:buNone/>
-            </a:pPr>
-            <a:r>
-              <a:rPr lang="en-US" sz="900" dirty="0">
-                <a:solidFill>
-                  <a:srgbClr val="615C52"/>
-                </a:solidFill>
-                <a:latin typeface="Inter" pitchFamily="34" charset="0"/>
-                <a:ea typeface="Inter" pitchFamily="34" charset="-122"/>
-                <a:cs typeface="Inter" pitchFamily="34" charset="-120"/>
-              </a:rPr>
-              <a:t>dotnetclaude.com</a:t>
-            </a:r>
-            <a:endParaRPr lang="en-US" sz="900" dirty="0"/>
-          </a:p>
-        </p:txBody>
-      </p:sp>
-      <p:sp>
-        <p:nvSpPr>
-          <p:cNvPr id="22" name="Text 16"/>
-          <p:cNvSpPr/>
-          <p:nvPr/>
-        </p:nvSpPr>
-        <p:spPr>
-          <a:xfrm>
-            <a:off x="4937760" y="4818888"/>
-            <a:ext cx="3657600" cy="274320"/>
-          </a:xfrm>
-          <a:prstGeom prst="rect">
-            <a:avLst/>
-          </a:prstGeom>
-          <a:noFill/>
-          <a:ln/>
-        </p:spPr>
-        <p:txBody>
-          <a:bodyPr wrap="square" rtlCol="0" anchor="ctr"/>
-          <a:lstStyle/>
-          <a:p>
-            <a:pPr marL="0" indent="0" algn="r">
-              <a:buNone/>
-            </a:pPr>
-            <a:r>
-              <a:rPr lang="en-US" sz="900" dirty="0">
-                <a:solidFill>
-                  <a:srgbClr val="615C52"/>
-                </a:solidFill>
-                <a:latin typeface="Inter" pitchFamily="34" charset="0"/>
-                <a:ea typeface="Inter" pitchFamily="34" charset="-122"/>
-                <a:cs typeface="Inter" pitchFamily="34" charset="-120"/>
-              </a:rPr>
-              <a:t>Section 1  ·  9/13</a:t>
-            </a:r>
-            <a:endParaRPr lang="en-US" sz="900" dirty="0"/>
-          </a:p>
-        </p:txBody>
-      </p:sp>
     </p:spTree>
   </p:cSld>
   <p:clrMapOvr>
@@ -10277,4 +12136,319 @@
     </a:ext>
   </a:extLst>
 </a:theme>
+</file>
+
+<file path=ppt/theme/theme2.xml><?xml version="1.0" encoding="utf-8"?>
+<a:theme xmlns:a="http://schemas.openxmlformats.org/drawingml/2006/main" name="Office Theme">
+  <a:themeElements>
+    <a:clrScheme name="Office">
+      <a:dk1>
+        <a:sysClr val="windowText" lastClr="000000"/>
+      </a:dk1>
+      <a:lt1>
+        <a:sysClr val="window" lastClr="FFFFFF"/>
+      </a:lt1>
+      <a:dk2>
+        <a:srgbClr val="0E2841"/>
+      </a:dk2>
+      <a:lt2>
+        <a:srgbClr val="E8E8E8"/>
+      </a:lt2>
+      <a:accent1>
+        <a:srgbClr val="156082"/>
+      </a:accent1>
+      <a:accent2>
+        <a:srgbClr val="E97132"/>
+      </a:accent2>
+      <a:accent3>
+        <a:srgbClr val="196B24"/>
+      </a:accent3>
+      <a:accent4>
+        <a:srgbClr val="0F9ED5"/>
+      </a:accent4>
+      <a:accent5>
+        <a:srgbClr val="A02B93"/>
+      </a:accent5>
+      <a:accent6>
+        <a:srgbClr val="4EA72E"/>
+      </a:accent6>
+      <a:hlink>
+        <a:srgbClr val="467886"/>
+      </a:hlink>
+      <a:folHlink>
+        <a:srgbClr val="96607D"/>
+      </a:folHlink>
+    </a:clrScheme>
+    <a:fontScheme name="Office">
+      <a:majorFont>
+        <a:latin typeface="Aptos Display" panose="02110004020202020204"/>
+        <a:ea typeface=""/>
+        <a:cs typeface=""/>
+        <a:font script="Jpan" typeface="游ゴシック Light"/>
+        <a:font script="Hang" typeface="맑은 고딕"/>
+        <a:font script="Hans" typeface="等线 Light"/>
+        <a:font script="Hant" typeface="新細明體"/>
+        <a:font script="Arab" typeface="Times New Roman"/>
+        <a:font script="Hebr" typeface="Times New Roman"/>
+        <a:font script="Thai" typeface="Angsana New"/>
+        <a:font script="Ethi" typeface="Nyala"/>
+        <a:font script="Beng" typeface="Vrinda"/>
+        <a:font script="Gujr" typeface="Shruti"/>
+        <a:font script="Khmr" typeface="MoolBoran"/>
+        <a:font script="Knda" typeface="Tunga"/>
+        <a:font script="Guru" typeface="Raavi"/>
+        <a:font script="Cans" typeface="Euphemia"/>
+        <a:font script="Cher" typeface="Plantagenet Cherokee"/>
+        <a:font script="Yiii" typeface="Microsoft Yi Baiti"/>
+        <a:font script="Tibt" typeface="Microsoft Himalaya"/>
+        <a:font script="Thaa" typeface="MV Boli"/>
+        <a:font script="Deva" typeface="Mangal"/>
+        <a:font script="Telu" typeface="Gautami"/>
+        <a:font script="Taml" typeface="Latha"/>
+        <a:font script="Syrc" typeface="Estrangelo Edessa"/>
+        <a:font script="Orya" typeface="Kalinga"/>
+        <a:font script="Mlym" typeface="Kartika"/>
+        <a:font script="Laoo" typeface="DokChampa"/>
+        <a:font script="Sinh" typeface="Iskoola Pota"/>
+        <a:font script="Mong" typeface="Mongolian Baiti"/>
+        <a:font script="Viet" typeface="Times New Roman"/>
+        <a:font script="Uigh" typeface="Microsoft Uighur"/>
+        <a:font script="Geor" typeface="Sylfaen"/>
+        <a:font script="Armn" typeface="Arial"/>
+        <a:font script="Bugi" typeface="Leelawadee UI"/>
+        <a:font script="Bopo" typeface="Microsoft JhengHei"/>
+        <a:font script="Java" typeface="Javanese Text"/>
+        <a:font script="Lisu" typeface="Segoe UI"/>
+        <a:font script="Mymr" typeface="Myanmar Text"/>
+        <a:font script="Nkoo" typeface="Ebrima"/>
+        <a:font script="Olck" typeface="Nirmala UI"/>
+        <a:font script="Osma" typeface="Ebrima"/>
+        <a:font script="Phag" typeface="Phagspa"/>
+        <a:font script="Syrn" typeface="Estrangelo Edessa"/>
+        <a:font script="Syrj" typeface="Estrangelo Edessa"/>
+        <a:font script="Syre" typeface="Estrangelo Edessa"/>
+        <a:font script="Sora" typeface="Nirmala UI"/>
+        <a:font script="Tale" typeface="Microsoft Tai Le"/>
+        <a:font script="Talu" typeface="Microsoft New Tai Lue"/>
+        <a:font script="Tfng" typeface="Ebrima"/>
+      </a:majorFont>
+      <a:minorFont>
+        <a:latin typeface="Aptos" panose="02110004020202020204"/>
+        <a:ea typeface=""/>
+        <a:cs typeface=""/>
+        <a:font script="Jpan" typeface="游ゴシック"/>
+        <a:font script="Hang" typeface="맑은 고딕"/>
+        <a:font script="Hans" typeface="等线"/>
+        <a:font script="Hant" typeface="新細明體"/>
+        <a:font script="Arab" typeface="Arial"/>
+        <a:font script="Hebr" typeface="Arial"/>
+        <a:font script="Thai" typeface="Cordia New"/>
+        <a:font script="Ethi" typeface="Nyala"/>
+        <a:font script="Beng" typeface="Vrinda"/>
+        <a:font script="Gujr" typeface="Shruti"/>
+        <a:font script="Khmr" typeface="DaunPenh"/>
+        <a:font script="Knda" typeface="Tunga"/>
+        <a:font script="Guru" typeface="Raavi"/>
+        <a:font script="Cans" typeface="Euphemia"/>
+        <a:font script="Cher" typeface="Plantagenet Cherokee"/>
+        <a:font script="Yiii" typeface="Microsoft Yi Baiti"/>
+        <a:font script="Tibt" typeface="Microsoft Himalaya"/>
+        <a:font script="Thaa" typeface="MV Boli"/>
+        <a:font script="Deva" typeface="Mangal"/>
+        <a:font script="Telu" typeface="Gautami"/>
+        <a:font script="Taml" typeface="Latha"/>
+        <a:font script="Syrc" typeface="Estrangelo Edessa"/>
+        <a:font script="Orya" typeface="Kalinga"/>
+        <a:font script="Mlym" typeface="Kartika"/>
+        <a:font script="Laoo" typeface="DokChampa"/>
+        <a:font script="Sinh" typeface="Iskoola Pota"/>
+        <a:font script="Mong" typeface="Mongolian Baiti"/>
+        <a:font script="Viet" typeface="Arial"/>
+        <a:font script="Uigh" typeface="Microsoft Uighur"/>
+        <a:font script="Geor" typeface="Sylfaen"/>
+        <a:font script="Armn" typeface="Arial"/>
+        <a:font script="Bugi" typeface="Leelawadee UI"/>
+        <a:font script="Bopo" typeface="Microsoft JhengHei"/>
+        <a:font script="Java" typeface="Javanese Text"/>
+        <a:font script="Lisu" typeface="Segoe UI"/>
+        <a:font script="Mymr" typeface="Myanmar Text"/>
+        <a:font script="Nkoo" typeface="Ebrima"/>
+        <a:font script="Olck" typeface="Nirmala UI"/>
+        <a:font script="Osma" typeface="Ebrima"/>
+        <a:font script="Phag" typeface="Phagspa"/>
+        <a:font script="Syrn" typeface="Estrangelo Edessa"/>
+        <a:font script="Syrj" typeface="Estrangelo Edessa"/>
+        <a:font script="Syre" typeface="Estrangelo Edessa"/>
+        <a:font script="Sora" typeface="Nirmala UI"/>
+        <a:font script="Tale" typeface="Microsoft Tai Le"/>
+        <a:font script="Talu" typeface="Microsoft New Tai Lue"/>
+        <a:font script="Tfng" typeface="Ebrima"/>
+      </a:minorFont>
+    </a:fontScheme>
+    <a:fmtScheme name="Office">
+      <a:fillStyleLst>
+        <a:solidFill>
+          <a:schemeClr val="phClr"/>
+        </a:solidFill>
+        <a:gradFill rotWithShape="1">
+          <a:gsLst>
+            <a:gs pos="0">
+              <a:schemeClr val="phClr">
+                <a:lumMod val="110000"/>
+                <a:satMod val="105000"/>
+                <a:tint val="67000"/>
+              </a:schemeClr>
+            </a:gs>
+            <a:gs pos="50000">
+              <a:schemeClr val="phClr">
+                <a:lumMod val="105000"/>
+                <a:satMod val="103000"/>
+                <a:tint val="73000"/>
+              </a:schemeClr>
+            </a:gs>
+            <a:gs pos="100000">
+              <a:schemeClr val="phClr">
+                <a:lumMod val="105000"/>
+                <a:satMod val="109000"/>
+                <a:tint val="81000"/>
+              </a:schemeClr>
+            </a:gs>
+          </a:gsLst>
+          <a:lin ang="5400000" scaled="0"/>
+        </a:gradFill>
+        <a:gradFill rotWithShape="1">
+          <a:gsLst>
+            <a:gs pos="0">
+              <a:schemeClr val="phClr">
+                <a:satMod val="103000"/>
+                <a:lumMod val="102000"/>
+                <a:tint val="94000"/>
+              </a:schemeClr>
+            </a:gs>
+            <a:gs pos="50000">
+              <a:schemeClr val="phClr">
+                <a:satMod val="110000"/>
+                <a:lumMod val="100000"/>
+                <a:shade val="100000"/>
+              </a:schemeClr>
+            </a:gs>
+            <a:gs pos="100000">
+              <a:schemeClr val="phClr">
+                <a:lumMod val="99000"/>
+                <a:satMod val="120000"/>
+                <a:shade val="78000"/>
+              </a:schemeClr>
+            </a:gs>
+          </a:gsLst>
+          <a:lin ang="5400000" scaled="0"/>
+        </a:gradFill>
+      </a:fillStyleLst>
+      <a:lnStyleLst>
+        <a:ln w="12700" cap="flat" cmpd="sng" algn="ctr">
+          <a:solidFill>
+            <a:schemeClr val="phClr"/>
+          </a:solidFill>
+          <a:prstDash val="solid"/>
+          <a:miter lim="800000"/>
+        </a:ln>
+        <a:ln w="19050" cap="flat" cmpd="sng" algn="ctr">
+          <a:solidFill>
+            <a:schemeClr val="phClr"/>
+          </a:solidFill>
+          <a:prstDash val="solid"/>
+          <a:miter lim="800000"/>
+        </a:ln>
+        <a:ln w="25400" cap="flat" cmpd="sng" algn="ctr">
+          <a:solidFill>
+            <a:schemeClr val="phClr"/>
+          </a:solidFill>
+          <a:prstDash val="solid"/>
+          <a:miter lim="800000"/>
+        </a:ln>
+      </a:lnStyleLst>
+      <a:effectStyleLst>
+        <a:effectStyle>
+          <a:effectLst/>
+        </a:effectStyle>
+        <a:effectStyle>
+          <a:effectLst/>
+        </a:effectStyle>
+        <a:effectStyle>
+          <a:effectLst>
+            <a:outerShdw blurRad="57150" dist="19050" dir="5400000" algn="ctr" rotWithShape="0">
+              <a:srgbClr val="000000">
+                <a:alpha val="63000"/>
+              </a:srgbClr>
+            </a:outerShdw>
+          </a:effectLst>
+        </a:effectStyle>
+      </a:effectStyleLst>
+      <a:bgFillStyleLst>
+        <a:solidFill>
+          <a:schemeClr val="phClr"/>
+        </a:solidFill>
+        <a:solidFill>
+          <a:schemeClr val="phClr">
+            <a:tint val="95000"/>
+            <a:satMod val="170000"/>
+          </a:schemeClr>
+        </a:solidFill>
+        <a:gradFill rotWithShape="1">
+          <a:gsLst>
+            <a:gs pos="0">
+              <a:schemeClr val="phClr">
+                <a:tint val="93000"/>
+                <a:satMod val="150000"/>
+                <a:shade val="98000"/>
+                <a:lumMod val="102000"/>
+              </a:schemeClr>
+            </a:gs>
+            <a:gs pos="50000">
+              <a:schemeClr val="phClr">
+                <a:tint val="98000"/>
+                <a:satMod val="130000"/>
+                <a:shade val="90000"/>
+                <a:lumMod val="103000"/>
+              </a:schemeClr>
+            </a:gs>
+            <a:gs pos="100000">
+              <a:schemeClr val="phClr">
+                <a:shade val="63000"/>
+                <a:satMod val="120000"/>
+              </a:schemeClr>
+            </a:gs>
+          </a:gsLst>
+          <a:lin ang="5400000" scaled="0"/>
+        </a:gradFill>
+      </a:bgFillStyleLst>
+    </a:fmtScheme>
+  </a:themeElements>
+  <a:objectDefaults>
+    <a:lnDef>
+      <a:spPr/>
+      <a:bodyPr/>
+      <a:lstStyle/>
+      <a:style>
+        <a:lnRef idx="2">
+          <a:schemeClr val="accent1"/>
+        </a:lnRef>
+        <a:fillRef idx="0">
+          <a:schemeClr val="accent1"/>
+        </a:fillRef>
+        <a:effectRef idx="1">
+          <a:schemeClr val="accent1"/>
+        </a:effectRef>
+        <a:fontRef idx="minor">
+          <a:schemeClr val="tx1"/>
+        </a:fontRef>
+      </a:style>
+    </a:lnDef>
+  </a:objectDefaults>
+  <a:extraClrSchemeLst/>
+  <a:extLst>
+    <a:ext uri="{05A4C25C-085E-4340-85A3-A5531E510DB2}">
+      <thm15:themeFamily xmlns:thm15="http://schemas.microsoft.com/office/thememl/2012/main" name="Office Theme" id="{2E142A2C-CD16-42D6-873A-C26D2A0506FA}" vid="{1BDDFF52-6CD6-40A5-AB3C-68EB2F1E4D0A}"/>
+    </a:ext>
+  </a:extLst>
+</a:theme>
 </file>
</xml_diff>

<commit_message>
updates to slide decks
</commit_message>
<xml_diff>
--- a/decks/Day 1/Section1-Foundations-Claude-Code-CLI.pptx
+++ b/decks/Day 1/Section1-Foundations-Claude-Code-CLI.pptx
@@ -1888,45 +1888,6 @@
           <a:lstStyle/>
           <a:p>
             <a:endParaRPr lang="en-US"/>
-          </a:p>
-        </p:txBody>
-      </p:sp>
-      <p:sp>
-        <p:nvSpPr>
-          <p:cNvPr id="8" name="Text 5"/>
-          <p:cNvSpPr/>
-          <p:nvPr/>
-        </p:nvSpPr>
-        <p:spPr>
-          <a:xfrm>
-            <a:off x="640080" y="3584448"/>
-            <a:ext cx="7315200" cy="365760"/>
-          </a:xfrm>
-          <a:prstGeom prst="rect">
-            <a:avLst/>
-          </a:prstGeom>
-          <a:noFill/>
-          <a:ln/>
-        </p:spPr>
-        <p:txBody>
-          <a:bodyPr wrap="square" lIns="0" tIns="0" rIns="0" bIns="0" rtlCol="0" anchor="ctr"/>
-          <a:lstStyle/>
-          <a:p>
-            <a:pPr marL="0" indent="0">
-              <a:buNone/>
-            </a:pPr>
-            <a:r>
-              <a:rPr lang="en-US" sz="1700" dirty="0">
-                <a:solidFill>
-                  <a:srgbClr val="615C52"/>
-                </a:solidFill>
-                <a:latin typeface="Inter" pitchFamily="34" charset="0"/>
-                <a:ea typeface="Inter" pitchFamily="34" charset="-122"/>
-                <a:cs typeface="Inter" pitchFamily="34" charset="-120"/>
-              </a:rPr>
-              <a:t>90 min  ·  40 lecture / demo  +  50 lab</a:t>
-            </a:r>
-            <a:endParaRPr lang="en-US" sz="1700" dirty="0"/>
           </a:p>
         </p:txBody>
       </p:sp>

</xml_diff>